<commit_message>
docs: Flarum 1.8.18 운영 배포 결과 반영
</commit_message>
<xml_diff>
--- a/output/presentation/techflow-flarum-1.8.18-upgrade.pptx
+++ b/output/presentation/techflow-flarum-1.8.18-upgrade.pptx
@@ -2,19 +2,19 @@
 <file path=ppt/presentation.xml><?xml version="1.0" encoding="utf-8"?>
 <p:presentation xmlns:p="http://schemas.openxmlformats.org/presentationml/2006/main">
   <p:sldMasterIdLst>
-    <p:sldMasterId xmlns:r="http://schemas.openxmlformats.org/officeDocument/2006/relationships" id="2147483648" r:id="R011615909ee442b0"/>
+    <p:sldMasterId xmlns:r="http://schemas.openxmlformats.org/officeDocument/2006/relationships" id="2147483648" r:id="R71327ab18cd74925"/>
   </p:sldMasterIdLst>
   <p:notesMasterIdLst>
-    <p:notesMasterId xmlns:r="http://schemas.openxmlformats.org/officeDocument/2006/relationships" r:id="R82ba07fccf92429f"/>
+    <p:notesMasterId xmlns:r="http://schemas.openxmlformats.org/officeDocument/2006/relationships" r:id="Rf0dab643b34a43c2"/>
   </p:notesMasterIdLst>
   <p:sldIdLst>
-    <p:sldId xmlns:r="http://schemas.openxmlformats.org/officeDocument/2006/relationships" id="256" r:id="R76edfe688a104f5b"/>
-    <p:sldId xmlns:r="http://schemas.openxmlformats.org/officeDocument/2006/relationships" id="257" r:id="R97343a4c2020478b"/>
-    <p:sldId xmlns:r="http://schemas.openxmlformats.org/officeDocument/2006/relationships" id="258" r:id="R4371b19e236d4486"/>
-    <p:sldId xmlns:r="http://schemas.openxmlformats.org/officeDocument/2006/relationships" id="259" r:id="Rea7c74f552074300"/>
-    <p:sldId xmlns:r="http://schemas.openxmlformats.org/officeDocument/2006/relationships" id="260" r:id="R788ed78e00224940"/>
-    <p:sldId xmlns:r="http://schemas.openxmlformats.org/officeDocument/2006/relationships" id="261" r:id="R045bb174534040dd"/>
-    <p:sldId xmlns:r="http://schemas.openxmlformats.org/officeDocument/2006/relationships" id="262" r:id="R440a94d56b514de5"/>
+    <p:sldId xmlns:r="http://schemas.openxmlformats.org/officeDocument/2006/relationships" id="256" r:id="R1cf03cd06b494a8a"/>
+    <p:sldId xmlns:r="http://schemas.openxmlformats.org/officeDocument/2006/relationships" id="257" r:id="R5c51aa1e3e3e4fda"/>
+    <p:sldId xmlns:r="http://schemas.openxmlformats.org/officeDocument/2006/relationships" id="258" r:id="Rd6bee34e98454c21"/>
+    <p:sldId xmlns:r="http://schemas.openxmlformats.org/officeDocument/2006/relationships" id="259" r:id="R3cee1c6fe4944852"/>
+    <p:sldId xmlns:r="http://schemas.openxmlformats.org/officeDocument/2006/relationships" id="260" r:id="R2951ddfd14d748b2"/>
+    <p:sldId xmlns:r="http://schemas.openxmlformats.org/officeDocument/2006/relationships" id="261" r:id="R1961692e9e0947f2"/>
+    <p:sldId xmlns:r="http://schemas.openxmlformats.org/officeDocument/2006/relationships" id="262" r:id="R8de6ce1573b749c6"/>
   </p:sldIdLst>
   <p:sldSz cx="12192000" cy="6858000"/>
   <p:notesSz cx="6858000" cy="9144000"/>
@@ -996,7 +996,7 @@
   </p:cSld>
   <p:clrMap bg1="lt1" tx1="dk1" bg2="lt2" tx2="dk2" accent1="accent1" accent2="accent2" accent3="accent3" accent4="accent4" accent5="accent5" accent6="accent6" hlink="hlink" folHlink="folHlink"/>
   <p:sldLayoutIdLst>
-    <p:sldLayoutId xmlns:r="http://schemas.openxmlformats.org/officeDocument/2006/relationships" id="2147483649" r:id="R0981246fd5454030"/>
+    <p:sldLayoutId xmlns:r="http://schemas.openxmlformats.org/officeDocument/2006/relationships" id="2147483649" r:id="Rd05e28e7786d45b8"/>
   </p:sldLayoutIdLst>
   <p:txStyles>
     <p:titleStyle>
@@ -1547,7 +1547,7 @@
           <p:cNvPr id="9" name="">
             <a:extLst xmlns:a="http://schemas.openxmlformats.org/drawingml/2006/main">
               <a:ext uri="{FF2B5EF4-FFF2-40B4-BE49-F238E27FC236}">
-                <a16:creationId xmlns:a16="http://schemas.microsoft.com/office/drawing/2014/main" id="{CF077184-D124-4C98-A599-B766A4483943}"/>
+                <a16:creationId xmlns:a16="http://schemas.microsoft.com/office/drawing/2014/main" id="{64245EE8-7115-4BB5-83D0-25406D246649}"/>
               </a:ext>
             </a:extLst>
           </p:cNvPr>
@@ -1605,7 +1605,7 @@
           <p:cNvPr id="2" name="">
             <a:extLst xmlns:a="http://schemas.openxmlformats.org/drawingml/2006/main">
               <a:ext uri="{FF2B5EF4-FFF2-40B4-BE49-F238E27FC236}">
-                <a16:creationId xmlns:a16="http://schemas.microsoft.com/office/drawing/2014/main" id="{E7CD6F1F-0E24-41DE-9619-2CF46E345E52}"/>
+                <a16:creationId xmlns:a16="http://schemas.microsoft.com/office/drawing/2014/main" id="{86D8AADD-2DDD-4D0B-9F4D-EB3693285880}"/>
               </a:ext>
             </a:extLst>
           </p:cNvPr>
@@ -1676,7 +1676,7 @@
                 <a:ea typeface="Malgun Gothic"/>
                 <a:cs typeface="Malgun Gothic"/>
               </a:rPr>
-              <a:t>업데이트 검증</a:t>
+              <a:t>운영 반영 완료</a:t>
             </a:r>
           </a:p>
         </p:txBody>
@@ -1686,7 +1686,7 @@
           <p:cNvPr id="3" name="">
             <a:extLst xmlns:a="http://schemas.openxmlformats.org/drawingml/2006/main">
               <a:ext uri="{FF2B5EF4-FFF2-40B4-BE49-F238E27FC236}">
-                <a16:creationId xmlns:a16="http://schemas.microsoft.com/office/drawing/2014/main" id="{7605087B-7C9D-4EF2-AB2D-AE5A63A3B9AD}"/>
+                <a16:creationId xmlns:a16="http://schemas.microsoft.com/office/drawing/2014/main" id="{F61D0885-F679-4E8A-9C54-22E14A711B9F}"/>
               </a:ext>
             </a:extLst>
           </p:cNvPr>
@@ -1734,7 +1734,7 @@
                 <a:ea typeface="Malgun Gothic"/>
                 <a:cs typeface="Malgun Gothic"/>
               </a:rPr>
-              <a:t>반복 롤백과 Community·TechFlow 회귀를</a:t>
+              <a:t>반복 롤백 검증을 거쳐 Community와</a:t>
             </a:r>
           </a:p>
           <a:p xmlns:a="http://schemas.openxmlformats.org/drawingml/2006/main">
@@ -1757,7 +1757,7 @@
                 <a:ea typeface="Malgun Gothic"/>
                 <a:cs typeface="Malgun Gothic"/>
               </a:rPr>
-              <a:t>운영 적용 전에 검증했습니다.</a:t>
+              <a:t>TechFlow 통합 상태까지 확인했습니다.</a:t>
             </a:r>
           </a:p>
         </p:txBody>
@@ -1767,7 +1767,7 @@
           <p:cNvPr id="4" name="">
             <a:extLst xmlns:a="http://schemas.openxmlformats.org/drawingml/2006/main">
               <a:ext uri="{FF2B5EF4-FFF2-40B4-BE49-F238E27FC236}">
-                <a16:creationId xmlns:a16="http://schemas.microsoft.com/office/drawing/2014/main" id="{5C3CD094-B827-41C0-92D4-B3DCF46D3A60}"/>
+                <a16:creationId xmlns:a16="http://schemas.microsoft.com/office/drawing/2014/main" id="{BB985292-32C4-4ECC-BD8C-F1AE53AD46E6}"/>
               </a:ext>
             </a:extLst>
           </p:cNvPr>
@@ -1800,7 +1800,7 @@
           <p:cNvPr id="5" name="">
             <a:extLst xmlns:a="http://schemas.openxmlformats.org/drawingml/2006/main">
               <a:ext uri="{FF2B5EF4-FFF2-40B4-BE49-F238E27FC236}">
-                <a16:creationId xmlns:a16="http://schemas.microsoft.com/office/drawing/2014/main" id="{4847EDB9-FD65-4A47-8739-65786FC5F17F}"/>
+                <a16:creationId xmlns:a16="http://schemas.microsoft.com/office/drawing/2014/main" id="{A17961D0-B932-43DB-A6BC-0715AD506986}"/>
               </a:ext>
             </a:extLst>
           </p:cNvPr>
@@ -1848,7 +1848,7 @@
                 <a:ea typeface="Malgun Gothic"/>
                 <a:cs typeface="Malgun Gothic"/>
               </a:rPr>
-              <a:t>조건부</a:t>
+              <a:t>GO</a:t>
             </a:r>
           </a:p>
           <a:p xmlns:a="http://schemas.openxmlformats.org/drawingml/2006/main">
@@ -1871,7 +1871,7 @@
                 <a:ea typeface="Malgun Gothic"/>
                 <a:cs typeface="Malgun Gothic"/>
               </a:rPr>
-              <a:t>GO</a:t>
+              <a:t>완료</a:t>
             </a:r>
           </a:p>
         </p:txBody>
@@ -1903,7 +1903,7 @@
           <p:cNvPr id="7" name="">
             <a:extLst xmlns:a="http://schemas.openxmlformats.org/drawingml/2006/main">
               <a:ext uri="{FF2B5EF4-FFF2-40B4-BE49-F238E27FC236}">
-                <a16:creationId xmlns:a16="http://schemas.microsoft.com/office/drawing/2014/main" id="{55074E22-42FE-4EE8-805A-771F6F071BCF}"/>
+                <a16:creationId xmlns:a16="http://schemas.microsoft.com/office/drawing/2014/main" id="{1899B3F0-9F57-4CAE-9C9A-233CB1EAC192}"/>
               </a:ext>
             </a:extLst>
           </p:cNvPr>
@@ -1951,7 +1951,7 @@
                 <a:ea typeface="Malgun Gothic"/>
                 <a:cs typeface="Malgun Gothic"/>
               </a:rPr>
-              <a:t>운영 서버 변경 없음</a:t>
+              <a:t>운영 1.8.18</a:t>
             </a:r>
           </a:p>
           <a:p xmlns:a="http://schemas.openxmlformats.org/drawingml/2006/main">
@@ -1974,7 +1974,7 @@
                 <a:ea typeface="Malgun Gothic"/>
                 <a:cs typeface="Malgun Gothic"/>
               </a:rPr>
-              <a:t>명시적 승인 후 배포</a:t>
+              <a:t>데이터 정합성 PASS</a:t>
             </a:r>
           </a:p>
         </p:txBody>
@@ -1984,7 +1984,7 @@
           <p:cNvPr id="8" name="">
             <a:extLst xmlns:a="http://schemas.openxmlformats.org/drawingml/2006/main">
               <a:ext uri="{FF2B5EF4-FFF2-40B4-BE49-F238E27FC236}">
-                <a16:creationId xmlns:a16="http://schemas.microsoft.com/office/drawing/2014/main" id="{EE00E233-2D3E-4CC8-BCAB-B10454BB6B74}"/>
+                <a16:creationId xmlns:a16="http://schemas.microsoft.com/office/drawing/2014/main" id="{2CE5B6F7-3185-4C49-9850-1928EAAAE9A3}"/>
               </a:ext>
             </a:extLst>
           </p:cNvPr>
@@ -2040,7 +2040,7 @@
     </p:spTree>
     <p:extLst>
       <p:ext uri="{BB962C8B-B14F-4D97-AF65-F5344CB8AC3E}">
-        <p14:creationId xmlns:p14="http://schemas.microsoft.com/office/powerpoint/2010/main" val="521222118"/>
+        <p14:creationId xmlns:p14="http://schemas.microsoft.com/office/powerpoint/2010/main" val="1005363372"/>
       </p:ext>
     </p:extLst>
   </p:cSld>
@@ -2071,7 +2071,7 @@
           <p:cNvPr id="18" name="">
             <a:extLst xmlns:a="http://schemas.openxmlformats.org/drawingml/2006/main">
               <a:ext uri="{FF2B5EF4-FFF2-40B4-BE49-F238E27FC236}">
-                <a16:creationId xmlns:a16="http://schemas.microsoft.com/office/drawing/2014/main" id="{7177DAD9-923F-465E-A701-8BDCEDC56C7C}"/>
+                <a16:creationId xmlns:a16="http://schemas.microsoft.com/office/drawing/2014/main" id="{E38F2357-B01B-417A-BD75-D03C49A52BCE}"/>
               </a:ext>
             </a:extLst>
           </p:cNvPr>
@@ -2129,7 +2129,7 @@
           <p:cNvPr id="2" name="">
             <a:extLst xmlns:a="http://schemas.openxmlformats.org/drawingml/2006/main">
               <a:ext uri="{FF2B5EF4-FFF2-40B4-BE49-F238E27FC236}">
-                <a16:creationId xmlns:a16="http://schemas.microsoft.com/office/drawing/2014/main" id="{85515539-566D-4C5F-83AC-1DBDDCE21997}"/>
+                <a16:creationId xmlns:a16="http://schemas.microsoft.com/office/drawing/2014/main" id="{C88B38D2-F6BC-43C8-8743-7808AC6D85FA}"/>
               </a:ext>
             </a:extLst>
           </p:cNvPr>
@@ -2177,7 +2177,7 @@
                 <a:ea typeface="Malgun Gothic"/>
                 <a:cs typeface="Malgun Gothic"/>
               </a:rPr>
-              <a:t>최종 패키지 집합으로 두 번 같은 결과를 얻었습니다</a:t>
+              <a:t>운영 업데이트와 통합 검증을 모두 통과했습니다</a:t>
             </a:r>
           </a:p>
         </p:txBody>
@@ -2209,7 +2209,7 @@
           <p:cNvPr id="4" name="">
             <a:extLst xmlns:a="http://schemas.openxmlformats.org/drawingml/2006/main">
               <a:ext uri="{FF2B5EF4-FFF2-40B4-BE49-F238E27FC236}">
-                <a16:creationId xmlns:a16="http://schemas.microsoft.com/office/drawing/2014/main" id="{4FCF6AC8-4806-4FDD-9564-FF5684EA6017}"/>
+                <a16:creationId xmlns:a16="http://schemas.microsoft.com/office/drawing/2014/main" id="{1ACEB1AC-B827-4FE7-A107-074D424DA30A}"/>
               </a:ext>
             </a:extLst>
           </p:cNvPr>
@@ -2267,7 +2267,7 @@
           <p:cNvPr id="5" name="">
             <a:extLst xmlns:a="http://schemas.openxmlformats.org/drawingml/2006/main">
               <a:ext uri="{FF2B5EF4-FFF2-40B4-BE49-F238E27FC236}">
-                <a16:creationId xmlns:a16="http://schemas.microsoft.com/office/drawing/2014/main" id="{2DA5C9E3-61D6-4D72-9C6C-F5297F7DDDC4}"/>
+                <a16:creationId xmlns:a16="http://schemas.microsoft.com/office/drawing/2014/main" id="{1337A4ED-E21B-477E-9D4B-AC659A1220E1}"/>
               </a:ext>
             </a:extLst>
           </p:cNvPr>
@@ -2315,7 +2315,7 @@
                 <a:ea typeface="Malgun Gothic"/>
                 <a:cs typeface="Malgun Gothic"/>
               </a:rPr>
-              <a:t>업데이트뿐 아니라 데이터와 첨부를 기준선으로 되돌리는 과정까지 반복했습니다.</a:t>
+              <a:t>스테이징 반복 검증에 이어 운영 데이터, 브라우저 화면과 자동화 서비스까지 확인했습니다.</a:t>
             </a:r>
           </a:p>
         </p:txBody>
@@ -2325,7 +2325,7 @@
           <p:cNvPr id="6" name="">
             <a:extLst xmlns:a="http://schemas.openxmlformats.org/drawingml/2006/main">
               <a:ext uri="{FF2B5EF4-FFF2-40B4-BE49-F238E27FC236}">
-                <a16:creationId xmlns:a16="http://schemas.microsoft.com/office/drawing/2014/main" id="{AF225A76-6424-4EF1-92A7-56C7EE1E76F9}"/>
+                <a16:creationId xmlns:a16="http://schemas.microsoft.com/office/drawing/2014/main" id="{421F21C7-32C3-4BF2-8D9F-737B524B7CB5}"/>
               </a:ext>
             </a:extLst>
           </p:cNvPr>
@@ -2358,7 +2358,7 @@
           <p:cNvPr id="7" name="">
             <a:extLst xmlns:a="http://schemas.openxmlformats.org/drawingml/2006/main">
               <a:ext uri="{FF2B5EF4-FFF2-40B4-BE49-F238E27FC236}">
-                <a16:creationId xmlns:a16="http://schemas.microsoft.com/office/drawing/2014/main" id="{50240698-B07C-4FF8-A90A-B367DB759261}"/>
+                <a16:creationId xmlns:a16="http://schemas.microsoft.com/office/drawing/2014/main" id="{C98FE75E-DC61-4B63-A668-CEDD4F2E3A42}"/>
               </a:ext>
             </a:extLst>
           </p:cNvPr>
@@ -2406,7 +2406,7 @@
                 <a:ea typeface="Malgun Gothic"/>
                 <a:cs typeface="Malgun Gothic"/>
               </a:rPr>
-              <a:t>2/2</a:t>
+              <a:t>1.8.18</a:t>
             </a:r>
           </a:p>
         </p:txBody>
@@ -2416,7 +2416,7 @@
           <p:cNvPr id="8" name="">
             <a:extLst xmlns:a="http://schemas.openxmlformats.org/drawingml/2006/main">
               <a:ext uri="{FF2B5EF4-FFF2-40B4-BE49-F238E27FC236}">
-                <a16:creationId xmlns:a16="http://schemas.microsoft.com/office/drawing/2014/main" id="{AA423F9A-60F5-4409-86F0-505B23CEDFE0}"/>
+                <a16:creationId xmlns:a16="http://schemas.microsoft.com/office/drawing/2014/main" id="{659B0659-310F-4961-83FA-21D4CF67C9C5}"/>
               </a:ext>
             </a:extLst>
           </p:cNvPr>
@@ -2464,7 +2464,7 @@
                 <a:ea typeface="Malgun Gothic"/>
                 <a:cs typeface="Malgun Gothic"/>
               </a:rPr>
-              <a:t>업데이트·롤백</a:t>
+              <a:t>운영 Flarum</a:t>
             </a:r>
           </a:p>
         </p:txBody>
@@ -2474,7 +2474,7 @@
           <p:cNvPr id="9" name="">
             <a:extLst xmlns:a="http://schemas.openxmlformats.org/drawingml/2006/main">
               <a:ext uri="{FF2B5EF4-FFF2-40B4-BE49-F238E27FC236}">
-                <a16:creationId xmlns:a16="http://schemas.microsoft.com/office/drawing/2014/main" id="{DEC6E156-1194-4B56-A305-05AF557DEDF8}"/>
+                <a16:creationId xmlns:a16="http://schemas.microsoft.com/office/drawing/2014/main" id="{D80D29E9-54EB-4260-85ED-08B0E810FD0C}"/>
               </a:ext>
             </a:extLst>
           </p:cNvPr>
@@ -2522,7 +2522,7 @@
                 <a:ea typeface="Malgun Gothic"/>
                 <a:cs typeface="Malgun Gothic"/>
               </a:rPr>
-              <a:t>validated-cycle-01과 03 모두 통과</a:t>
+              <a:t>Nicknames 1.8.3 · SMTP · Debug Off</a:t>
             </a:r>
           </a:p>
         </p:txBody>
@@ -2532,7 +2532,7 @@
           <p:cNvPr id="10" name="">
             <a:extLst xmlns:a="http://schemas.openxmlformats.org/drawingml/2006/main">
               <a:ext uri="{FF2B5EF4-FFF2-40B4-BE49-F238E27FC236}">
-                <a16:creationId xmlns:a16="http://schemas.microsoft.com/office/drawing/2014/main" id="{5ED9ED13-26B9-4756-A745-BA93A4BBCD40}"/>
+                <a16:creationId xmlns:a16="http://schemas.microsoft.com/office/drawing/2014/main" id="{52E8D0B6-8000-46E6-8416-6E7116716F6A}"/>
               </a:ext>
             </a:extLst>
           </p:cNvPr>
@@ -2565,7 +2565,7 @@
           <p:cNvPr id="11" name="">
             <a:extLst xmlns:a="http://schemas.openxmlformats.org/drawingml/2006/main">
               <a:ext uri="{FF2B5EF4-FFF2-40B4-BE49-F238E27FC236}">
-                <a16:creationId xmlns:a16="http://schemas.microsoft.com/office/drawing/2014/main" id="{E76CE31F-22FA-4872-B362-0F795414A619}"/>
+                <a16:creationId xmlns:a16="http://schemas.microsoft.com/office/drawing/2014/main" id="{30307CB3-E6F3-4220-A8DA-3ACED8BC9BED}"/>
               </a:ext>
             </a:extLst>
           </p:cNvPr>
@@ -2613,7 +2613,7 @@
                 <a:ea typeface="Malgun Gothic"/>
                 <a:cs typeface="Malgun Gothic"/>
               </a:rPr>
-              <a:t>216</a:t>
+              <a:t>0</a:t>
             </a:r>
           </a:p>
         </p:txBody>
@@ -2623,7 +2623,7 @@
           <p:cNvPr id="12" name="">
             <a:extLst xmlns:a="http://schemas.openxmlformats.org/drawingml/2006/main">
               <a:ext uri="{FF2B5EF4-FFF2-40B4-BE49-F238E27FC236}">
-                <a16:creationId xmlns:a16="http://schemas.microsoft.com/office/drawing/2014/main" id="{6B47442E-3F0A-41AF-8FF8-47D8687D6B3E}"/>
+                <a16:creationId xmlns:a16="http://schemas.microsoft.com/office/drawing/2014/main" id="{118CC8E9-532C-4C6B-B594-3E3FA8C5BBD9}"/>
               </a:ext>
             </a:extLst>
           </p:cNvPr>
@@ -2671,7 +2671,7 @@
                 <a:ea typeface="Malgun Gothic"/>
                 <a:cs typeface="Malgun Gothic"/>
               </a:rPr>
-              <a:t>TechFlow 테스트</a:t>
+              <a:t>데이터 차이</a:t>
             </a:r>
           </a:p>
         </p:txBody>
@@ -2681,7 +2681,7 @@
           <p:cNvPr id="13" name="">
             <a:extLst xmlns:a="http://schemas.openxmlformats.org/drawingml/2006/main">
               <a:ext uri="{FF2B5EF4-FFF2-40B4-BE49-F238E27FC236}">
-                <a16:creationId xmlns:a16="http://schemas.microsoft.com/office/drawing/2014/main" id="{6A533990-5EBB-4DCD-8615-7C180FF336D5}"/>
+                <a16:creationId xmlns:a16="http://schemas.microsoft.com/office/drawing/2014/main" id="{30788539-D3C5-4F49-8EA6-7F0708D95DFF}"/>
               </a:ext>
             </a:extLst>
           </p:cNvPr>
@@ -2729,7 +2729,7 @@
                 <a:ea typeface="Malgun Gothic"/>
                 <a:cs typeface="Malgun Gothic"/>
               </a:rPr>
-              <a:t>AI 답변·Chat·대화·KB 계약 통과</a:t>
+              <a:t>39명 · 토론 120 · 게시물 320 · 첨부 115</a:t>
             </a:r>
           </a:p>
         </p:txBody>
@@ -2739,7 +2739,7 @@
           <p:cNvPr id="14" name="">
             <a:extLst xmlns:a="http://schemas.openxmlformats.org/drawingml/2006/main">
               <a:ext uri="{FF2B5EF4-FFF2-40B4-BE49-F238E27FC236}">
-                <a16:creationId xmlns:a16="http://schemas.microsoft.com/office/drawing/2014/main" id="{AE9E9F63-2F42-4DF7-9D22-34AA5D4C8965}"/>
+                <a16:creationId xmlns:a16="http://schemas.microsoft.com/office/drawing/2014/main" id="{24D2EBFE-DDFA-4710-B76C-2EA700668014}"/>
               </a:ext>
             </a:extLst>
           </p:cNvPr>
@@ -2772,7 +2772,7 @@
           <p:cNvPr id="15" name="">
             <a:extLst xmlns:a="http://schemas.openxmlformats.org/drawingml/2006/main">
               <a:ext uri="{FF2B5EF4-FFF2-40B4-BE49-F238E27FC236}">
-                <a16:creationId xmlns:a16="http://schemas.microsoft.com/office/drawing/2014/main" id="{507B0B55-7BBE-4EA6-B6D9-7B203B30C717}"/>
+                <a16:creationId xmlns:a16="http://schemas.microsoft.com/office/drawing/2014/main" id="{59A28EC9-7BFD-48CB-9076-33DEBEDE24C4}"/>
               </a:ext>
             </a:extLst>
           </p:cNvPr>
@@ -2820,7 +2820,7 @@
                 <a:ea typeface="Malgun Gothic"/>
                 <a:cs typeface="Malgun Gothic"/>
               </a:rPr>
-              <a:t>0</a:t>
+              <a:t>PASS</a:t>
             </a:r>
           </a:p>
         </p:txBody>
@@ -2830,7 +2830,7 @@
           <p:cNvPr id="16" name="">
             <a:extLst xmlns:a="http://schemas.openxmlformats.org/drawingml/2006/main">
               <a:ext uri="{FF2B5EF4-FFF2-40B4-BE49-F238E27FC236}">
-                <a16:creationId xmlns:a16="http://schemas.microsoft.com/office/drawing/2014/main" id="{BB97E9D2-A8C1-4259-9445-CCE6993DEA2A}"/>
+                <a16:creationId xmlns:a16="http://schemas.microsoft.com/office/drawing/2014/main" id="{846BF7FE-56A0-46A9-9B22-2580CEAF6937}"/>
               </a:ext>
             </a:extLst>
           </p:cNvPr>
@@ -2878,7 +2878,7 @@
                 <a:ea typeface="Malgun Gothic"/>
                 <a:cs typeface="Malgun Gothic"/>
               </a:rPr>
-              <a:t>한글 내부 키</a:t>
+              <a:t>TechFlow 통합</a:t>
             </a:r>
           </a:p>
         </p:txBody>
@@ -2888,7 +2888,7 @@
           <p:cNvPr id="17" name="">
             <a:extLst xmlns:a="http://schemas.openxmlformats.org/drawingml/2006/main">
               <a:ext uri="{FF2B5EF4-FFF2-40B4-BE49-F238E27FC236}">
-                <a16:creationId xmlns:a16="http://schemas.microsoft.com/office/drawing/2014/main" id="{54CC8AF9-6987-4D6D-BA6E-4EDE5D86BF09}"/>
+                <a16:creationId xmlns:a16="http://schemas.microsoft.com/office/drawing/2014/main" id="{9FC53A2F-5AFD-4884-A05A-5C6F4CF2D7D5}"/>
               </a:ext>
             </a:extLst>
           </p:cNvPr>
@@ -2936,7 +2936,7 @@
                 <a:ea typeface="Malgun Gothic"/>
                 <a:cs typeface="Malgun Gothic"/>
               </a:rPr>
-              <a:t>Forum과 Admin에서 노출 없음</a:t>
+              <a:t>Poller 회복 · AI Gateway · Activepieces</a:t>
             </a:r>
           </a:p>
         </p:txBody>
@@ -2944,7 +2944,7 @@
     </p:spTree>
     <p:extLst>
       <p:ext uri="{BB962C8B-B14F-4D97-AF65-F5344CB8AC3E}">
-        <p14:creationId xmlns:p14="http://schemas.microsoft.com/office/powerpoint/2010/main" val="1017803801"/>
+        <p14:creationId xmlns:p14="http://schemas.microsoft.com/office/powerpoint/2010/main" val="647669435"/>
       </p:ext>
     </p:extLst>
   </p:cSld>
@@ -2975,7 +2975,7 @@
           <p:cNvPr id="23" name="">
             <a:extLst xmlns:a="http://schemas.openxmlformats.org/drawingml/2006/main">
               <a:ext uri="{FF2B5EF4-FFF2-40B4-BE49-F238E27FC236}">
-                <a16:creationId xmlns:a16="http://schemas.microsoft.com/office/drawing/2014/main" id="{1B4B6DFF-6757-4F08-A5A1-12E2C624C216}"/>
+                <a16:creationId xmlns:a16="http://schemas.microsoft.com/office/drawing/2014/main" id="{E2B4C97B-2B2E-46E3-B6FC-F74E32E3F030}"/>
               </a:ext>
             </a:extLst>
           </p:cNvPr>
@@ -3033,7 +3033,7 @@
           <p:cNvPr id="2" name="">
             <a:extLst xmlns:a="http://schemas.openxmlformats.org/drawingml/2006/main">
               <a:ext uri="{FF2B5EF4-FFF2-40B4-BE49-F238E27FC236}">
-                <a16:creationId xmlns:a16="http://schemas.microsoft.com/office/drawing/2014/main" id="{E490164C-2683-49B4-B8EF-945CBEBEB899}"/>
+                <a16:creationId xmlns:a16="http://schemas.microsoft.com/office/drawing/2014/main" id="{AA6F3B8C-39E7-4A71-B585-D85B7DC246EC}"/>
               </a:ext>
             </a:extLst>
           </p:cNvPr>
@@ -3081,7 +3081,7 @@
                 <a:ea typeface="Malgun Gothic"/>
                 <a:cs typeface="Malgun Gothic"/>
               </a:rPr>
-              <a:t>한 사이클은 복원 가능성까지 끝내야 완료입니다</a:t>
+              <a:t>첫 실행의 자동 롤백이 두 번째 성공을 안전하게 만들었습니다</a:t>
             </a:r>
           </a:p>
         </p:txBody>
@@ -3113,7 +3113,7 @@
           <p:cNvPr id="4" name="">
             <a:extLst xmlns:a="http://schemas.openxmlformats.org/drawingml/2006/main">
               <a:ext uri="{FF2B5EF4-FFF2-40B4-BE49-F238E27FC236}">
-                <a16:creationId xmlns:a16="http://schemas.microsoft.com/office/drawing/2014/main" id="{A51FB708-2A2E-4558-942A-C78A826C156B}"/>
+                <a16:creationId xmlns:a16="http://schemas.microsoft.com/office/drawing/2014/main" id="{1B021DE7-FC1C-41F4-869D-AD5016126019}"/>
               </a:ext>
             </a:extLst>
           </p:cNvPr>
@@ -3193,7 +3193,7 @@
           <p:cNvPr id="6" name="">
             <a:extLst xmlns:a="http://schemas.openxmlformats.org/drawingml/2006/main">
               <a:ext uri="{FF2B5EF4-FFF2-40B4-BE49-F238E27FC236}">
-                <a16:creationId xmlns:a16="http://schemas.microsoft.com/office/drawing/2014/main" id="{50123871-947F-42A5-8B4C-A180448654E5}"/>
+                <a16:creationId xmlns:a16="http://schemas.microsoft.com/office/drawing/2014/main" id="{D2140A25-E74B-4869-8980-934647DC9641}"/>
               </a:ext>
             </a:extLst>
           </p:cNvPr>
@@ -3226,7 +3226,7 @@
           <p:cNvPr id="7" name="">
             <a:extLst xmlns:a="http://schemas.openxmlformats.org/drawingml/2006/main">
               <a:ext uri="{FF2B5EF4-FFF2-40B4-BE49-F238E27FC236}">
-                <a16:creationId xmlns:a16="http://schemas.microsoft.com/office/drawing/2014/main" id="{AB260AF9-64A2-4D4D-BC5B-224F84750C66}"/>
+                <a16:creationId xmlns:a16="http://schemas.microsoft.com/office/drawing/2014/main" id="{802CC044-AB2E-492E-AF73-42A2479F9E19}"/>
               </a:ext>
             </a:extLst>
           </p:cNvPr>
@@ -3284,7 +3284,7 @@
           <p:cNvPr id="8" name="">
             <a:extLst xmlns:a="http://schemas.openxmlformats.org/drawingml/2006/main">
               <a:ext uri="{FF2B5EF4-FFF2-40B4-BE49-F238E27FC236}">
-                <a16:creationId xmlns:a16="http://schemas.microsoft.com/office/drawing/2014/main" id="{831DAFD4-A68C-4A3B-A9E2-82E5A551FEB7}"/>
+                <a16:creationId xmlns:a16="http://schemas.microsoft.com/office/drawing/2014/main" id="{EE75A803-A8A2-42D2-84E6-FFE846CFB82C}"/>
               </a:ext>
             </a:extLst>
           </p:cNvPr>
@@ -3332,7 +3332,7 @@
                 <a:ea typeface="Malgun Gothic"/>
                 <a:cs typeface="Malgun Gothic"/>
               </a:rPr>
-              <a:t>동일 시점 백업</a:t>
+              <a:t>첫 실행</a:t>
             </a:r>
           </a:p>
         </p:txBody>
@@ -3342,7 +3342,7 @@
           <p:cNvPr id="9" name="">
             <a:extLst xmlns:a="http://schemas.openxmlformats.org/drawingml/2006/main">
               <a:ext uri="{FF2B5EF4-FFF2-40B4-BE49-F238E27FC236}">
-                <a16:creationId xmlns:a16="http://schemas.microsoft.com/office/drawing/2014/main" id="{5756F5DC-8CA1-4127-99AB-F0F42541394A}"/>
+                <a16:creationId xmlns:a16="http://schemas.microsoft.com/office/drawing/2014/main" id="{ABDF0B8E-7580-48C9-AA80-E09A42A807FA}"/>
               </a:ext>
             </a:extLst>
           </p:cNvPr>
@@ -3367,7 +3367,7 @@
         </p:spPr>
         <p:txBody>
           <a:bodyPr xmlns:a="http://schemas.openxmlformats.org/drawingml/2006/main">
-            <a:normAutofit fontScale="100000"/>
+            <a:normAutofit fontScale="99383"/>
           </a:bodyPr>
           <a:lstStyle xmlns:a="http://schemas.openxmlformats.org/drawingml/2006/main"/>
           <a:p xmlns:a="http://schemas.openxmlformats.org/drawingml/2006/main">
@@ -3390,7 +3390,7 @@
                 <a:ea typeface="Malgun Gothic"/>
                 <a:cs typeface="Malgun Gothic"/>
               </a:rPr>
-              <a:t>앱·설정·DB·업로드를</a:t>
+              <a:t>공개 URL 자체 점검이</a:t>
             </a:r>
           </a:p>
           <a:p xmlns:a="http://schemas.openxmlformats.org/drawingml/2006/main">
@@ -3413,7 +3413,7 @@
                 <a:ea typeface="Malgun Gothic"/>
                 <a:cs typeface="Malgun Gothic"/>
               </a:rPr>
-              <a:t>한 변경 ID로 묶음</a:t>
+              <a:t>NAT loopback으로 시간 초과</a:t>
             </a:r>
           </a:p>
         </p:txBody>
@@ -3423,7 +3423,7 @@
           <p:cNvPr id="10" name="">
             <a:extLst xmlns:a="http://schemas.openxmlformats.org/drawingml/2006/main">
               <a:ext uri="{FF2B5EF4-FFF2-40B4-BE49-F238E27FC236}">
-                <a16:creationId xmlns:a16="http://schemas.microsoft.com/office/drawing/2014/main" id="{B19730DE-2065-4C67-A080-0A1AB79F9864}"/>
+                <a16:creationId xmlns:a16="http://schemas.microsoft.com/office/drawing/2014/main" id="{038D524E-5FBA-4390-95C6-44B51AD9D0DD}"/>
               </a:ext>
             </a:extLst>
           </p:cNvPr>
@@ -3456,7 +3456,7 @@
           <p:cNvPr id="11" name="">
             <a:extLst xmlns:a="http://schemas.openxmlformats.org/drawingml/2006/main">
               <a:ext uri="{FF2B5EF4-FFF2-40B4-BE49-F238E27FC236}">
-                <a16:creationId xmlns:a16="http://schemas.microsoft.com/office/drawing/2014/main" id="{81455E3D-D157-43AD-9C3F-0641036532D5}"/>
+                <a16:creationId xmlns:a16="http://schemas.microsoft.com/office/drawing/2014/main" id="{CD8A4271-1AEF-4FED-8C3A-C74448C009C4}"/>
               </a:ext>
             </a:extLst>
           </p:cNvPr>
@@ -3514,7 +3514,7 @@
           <p:cNvPr id="12" name="">
             <a:extLst xmlns:a="http://schemas.openxmlformats.org/drawingml/2006/main">
               <a:ext uri="{FF2B5EF4-FFF2-40B4-BE49-F238E27FC236}">
-                <a16:creationId xmlns:a16="http://schemas.microsoft.com/office/drawing/2014/main" id="{CFDAD816-D63B-478A-A671-A128FDD956A6}"/>
+                <a16:creationId xmlns:a16="http://schemas.microsoft.com/office/drawing/2014/main" id="{EDEE2874-18BC-4C2F-957A-356AEF1A1B94}"/>
               </a:ext>
             </a:extLst>
           </p:cNvPr>
@@ -3562,7 +3562,7 @@
                 <a:ea typeface="Malgun Gothic"/>
                 <a:cs typeface="Malgun Gothic"/>
               </a:rPr>
-              <a:t>사전 계산</a:t>
+              <a:t>자동 롤백</a:t>
             </a:r>
           </a:p>
         </p:txBody>
@@ -3572,7 +3572,7 @@
           <p:cNvPr id="13" name="">
             <a:extLst xmlns:a="http://schemas.openxmlformats.org/drawingml/2006/main">
               <a:ext uri="{FF2B5EF4-FFF2-40B4-BE49-F238E27FC236}">
-                <a16:creationId xmlns:a16="http://schemas.microsoft.com/office/drawing/2014/main" id="{13E61924-635A-4A61-9700-A929A371680E}"/>
+                <a16:creationId xmlns:a16="http://schemas.microsoft.com/office/drawing/2014/main" id="{68D5BBA1-6342-4512-8C8D-5EF5F446ED14}"/>
               </a:ext>
             </a:extLst>
           </p:cNvPr>
@@ -3620,7 +3620,7 @@
                 <a:ea typeface="Malgun Gothic"/>
                 <a:cs typeface="Malgun Gothic"/>
               </a:rPr>
-              <a:t>Composer 호환성과</a:t>
+              <a:t>1.8.10과 데이터 기준선을</a:t>
             </a:r>
           </a:p>
           <a:p xmlns:a="http://schemas.openxmlformats.org/drawingml/2006/main">
@@ -3643,7 +3643,7 @@
                 <a:ea typeface="Malgun Gothic"/>
                 <a:cs typeface="Malgun Gothic"/>
               </a:rPr>
-              <a:t>변경 패키지를 고정</a:t>
+              <a:t>차이 없이 복원</a:t>
             </a:r>
           </a:p>
         </p:txBody>
@@ -3653,7 +3653,7 @@
           <p:cNvPr id="14" name="">
             <a:extLst xmlns:a="http://schemas.openxmlformats.org/drawingml/2006/main">
               <a:ext uri="{FF2B5EF4-FFF2-40B4-BE49-F238E27FC236}">
-                <a16:creationId xmlns:a16="http://schemas.microsoft.com/office/drawing/2014/main" id="{01E675FF-8095-4545-9EF5-7AA5574CB65E}"/>
+                <a16:creationId xmlns:a16="http://schemas.microsoft.com/office/drawing/2014/main" id="{1698BE6B-B046-4864-BAF0-41CCA7984091}"/>
               </a:ext>
             </a:extLst>
           </p:cNvPr>
@@ -3686,7 +3686,7 @@
           <p:cNvPr id="15" name="">
             <a:extLst xmlns:a="http://schemas.openxmlformats.org/drawingml/2006/main">
               <a:ext uri="{FF2B5EF4-FFF2-40B4-BE49-F238E27FC236}">
-                <a16:creationId xmlns:a16="http://schemas.microsoft.com/office/drawing/2014/main" id="{A988591F-98A7-48D6-BBB6-2D30F41FD5F0}"/>
+                <a16:creationId xmlns:a16="http://schemas.microsoft.com/office/drawing/2014/main" id="{93F5FF81-77B1-4A46-AFD1-A71ECE5FBA9B}"/>
               </a:ext>
             </a:extLst>
           </p:cNvPr>
@@ -3744,7 +3744,7 @@
           <p:cNvPr id="16" name="">
             <a:extLst xmlns:a="http://schemas.openxmlformats.org/drawingml/2006/main">
               <a:ext uri="{FF2B5EF4-FFF2-40B4-BE49-F238E27FC236}">
-                <a16:creationId xmlns:a16="http://schemas.microsoft.com/office/drawing/2014/main" id="{735DBF57-C182-4679-9BC1-26074872ED51}"/>
+                <a16:creationId xmlns:a16="http://schemas.microsoft.com/office/drawing/2014/main" id="{6236B897-4B94-4183-B15B-C490AE6DE9ED}"/>
               </a:ext>
             </a:extLst>
           </p:cNvPr>
@@ -3792,7 +3792,7 @@
                 <a:ea typeface="Malgun Gothic"/>
                 <a:cs typeface="Malgun Gothic"/>
               </a:rPr>
-              <a:t>업데이트·검증</a:t>
+              <a:t>점검 경로 보정</a:t>
             </a:r>
           </a:p>
         </p:txBody>
@@ -3802,7 +3802,7 @@
           <p:cNvPr id="17" name="">
             <a:extLst xmlns:a="http://schemas.openxmlformats.org/drawingml/2006/main">
               <a:ext uri="{FF2B5EF4-FFF2-40B4-BE49-F238E27FC236}">
-                <a16:creationId xmlns:a16="http://schemas.microsoft.com/office/drawing/2014/main" id="{53A98692-242E-401E-AFD2-07B98A8E41B2}"/>
+                <a16:creationId xmlns:a16="http://schemas.microsoft.com/office/drawing/2014/main" id="{846DF7E2-7E0C-4CC6-A4C5-FCF3A73825BC}"/>
               </a:ext>
             </a:extLst>
           </p:cNvPr>
@@ -3850,7 +3850,7 @@
                 <a:ea typeface="Malgun Gothic"/>
                 <a:cs typeface="Malgun Gothic"/>
               </a:rPr>
-              <a:t>Migration·한글 Asset·</a:t>
+              <a:t>127.0.0.1과 실제 Host·</a:t>
             </a:r>
           </a:p>
           <a:p xmlns:a="http://schemas.openxmlformats.org/drawingml/2006/main">
@@ -3873,7 +3873,7 @@
                 <a:ea typeface="Malgun Gothic"/>
                 <a:cs typeface="Malgun Gothic"/>
               </a:rPr>
-              <a:t>Community 기능 확인</a:t>
+              <a:t>HTTPS 전달 헤더 사용</a:t>
             </a:r>
           </a:p>
         </p:txBody>
@@ -3883,7 +3883,7 @@
           <p:cNvPr id="18" name="">
             <a:extLst xmlns:a="http://schemas.openxmlformats.org/drawingml/2006/main">
               <a:ext uri="{FF2B5EF4-FFF2-40B4-BE49-F238E27FC236}">
-                <a16:creationId xmlns:a16="http://schemas.microsoft.com/office/drawing/2014/main" id="{BCF7A77D-F598-4820-B9C9-802AB9D2C696}"/>
+                <a16:creationId xmlns:a16="http://schemas.microsoft.com/office/drawing/2014/main" id="{40D00851-398D-4D97-8D56-56AF926329EB}"/>
               </a:ext>
             </a:extLst>
           </p:cNvPr>
@@ -3916,7 +3916,7 @@
           <p:cNvPr id="19" name="">
             <a:extLst xmlns:a="http://schemas.openxmlformats.org/drawingml/2006/main">
               <a:ext uri="{FF2B5EF4-FFF2-40B4-BE49-F238E27FC236}">
-                <a16:creationId xmlns:a16="http://schemas.microsoft.com/office/drawing/2014/main" id="{4CB3C2B5-8CD0-4A44-986A-7955235CC573}"/>
+                <a16:creationId xmlns:a16="http://schemas.microsoft.com/office/drawing/2014/main" id="{98CF8056-1CDB-44C2-90D9-CDA7B9E9D6BF}"/>
               </a:ext>
             </a:extLst>
           </p:cNvPr>
@@ -3974,7 +3974,7 @@
           <p:cNvPr id="20" name="">
             <a:extLst xmlns:a="http://schemas.openxmlformats.org/drawingml/2006/main">
               <a:ext uri="{FF2B5EF4-FFF2-40B4-BE49-F238E27FC236}">
-                <a16:creationId xmlns:a16="http://schemas.microsoft.com/office/drawing/2014/main" id="{E17965E9-1EC1-408B-8AAC-1FC0C34F7E99}"/>
+                <a16:creationId xmlns:a16="http://schemas.microsoft.com/office/drawing/2014/main" id="{CCBD26DE-C03B-4240-8A73-CB100D83B1BD}"/>
               </a:ext>
             </a:extLst>
           </p:cNvPr>
@@ -4022,7 +4022,7 @@
                 <a:ea typeface="Malgun Gothic"/>
                 <a:cs typeface="Malgun Gothic"/>
               </a:rPr>
-              <a:t>복원·정합성</a:t>
+              <a:t>두 번째 성공</a:t>
             </a:r>
           </a:p>
         </p:txBody>
@@ -4032,7 +4032,7 @@
           <p:cNvPr id="21" name="">
             <a:extLst xmlns:a="http://schemas.openxmlformats.org/drawingml/2006/main">
               <a:ext uri="{FF2B5EF4-FFF2-40B4-BE49-F238E27FC236}">
-                <a16:creationId xmlns:a16="http://schemas.microsoft.com/office/drawing/2014/main" id="{C4671B46-91F7-4AE6-B88A-79EBB6320EB4}"/>
+                <a16:creationId xmlns:a16="http://schemas.microsoft.com/office/drawing/2014/main" id="{5819F0D3-36E7-4C2F-BE8D-1E9E27FCCEBC}"/>
               </a:ext>
             </a:extLst>
           </p:cNvPr>
@@ -4080,7 +4080,7 @@
                 <a:ea typeface="Malgun Gothic"/>
                 <a:cs typeface="Malgun Gothic"/>
               </a:rPr>
-              <a:t>업무 DB와 첨부 해시를</a:t>
+              <a:t>1.8.18 유지·브라우저·</a:t>
             </a:r>
           </a:p>
           <a:p xmlns:a="http://schemas.openxmlformats.org/drawingml/2006/main">
@@ -4103,7 +4103,7 @@
                 <a:ea typeface="Malgun Gothic"/>
                 <a:cs typeface="Malgun Gothic"/>
               </a:rPr>
-              <a:t>기준선과 비교</a:t>
+              <a:t>TechFlow 통합 확인</a:t>
             </a:r>
           </a:p>
         </p:txBody>
@@ -4113,7 +4113,7 @@
           <p:cNvPr id="22" name="">
             <a:extLst xmlns:a="http://schemas.openxmlformats.org/drawingml/2006/main">
               <a:ext uri="{FF2B5EF4-FFF2-40B4-BE49-F238E27FC236}">
-                <a16:creationId xmlns:a16="http://schemas.microsoft.com/office/drawing/2014/main" id="{8729D74F-38CB-4226-9113-31D12761CE79}"/>
+                <a16:creationId xmlns:a16="http://schemas.microsoft.com/office/drawing/2014/main" id="{E9AB75A9-8E5A-4250-802A-8B72EEB6359A}"/>
               </a:ext>
             </a:extLst>
           </p:cNvPr>
@@ -4161,7 +4161,7 @@
                 <a:ea typeface="Malgun Gothic"/>
                 <a:cs typeface="Malgun Gothic"/>
               </a:rPr>
-              <a:t>실패하면 운영 전환 없이 같은 창에서 1.8.10 기준선으로 복원합니다.</a:t>
+              <a:t>두 실행의 백업과 첫 실행의 빈 rollback.diff를 운영 증적으로 보존합니다.</a:t>
             </a:r>
           </a:p>
         </p:txBody>
@@ -4169,7 +4169,7 @@
     </p:spTree>
     <p:extLst>
       <p:ext uri="{BB962C8B-B14F-4D97-AF65-F5344CB8AC3E}">
-        <p14:creationId xmlns:p14="http://schemas.microsoft.com/office/powerpoint/2010/main" val="454079601"/>
+        <p14:creationId xmlns:p14="http://schemas.microsoft.com/office/powerpoint/2010/main" val="1372191896"/>
       </p:ext>
     </p:extLst>
   </p:cSld>
@@ -4200,7 +4200,7 @@
           <p:cNvPr id="62" name="">
             <a:extLst xmlns:a="http://schemas.openxmlformats.org/drawingml/2006/main">
               <a:ext uri="{FF2B5EF4-FFF2-40B4-BE49-F238E27FC236}">
-                <a16:creationId xmlns:a16="http://schemas.microsoft.com/office/drawing/2014/main" id="{3F54622B-F55A-4267-9BE1-53847FC15893}"/>
+                <a16:creationId xmlns:a16="http://schemas.microsoft.com/office/drawing/2014/main" id="{20102682-FABF-41BE-8928-AD6AA8EA63B1}"/>
               </a:ext>
             </a:extLst>
           </p:cNvPr>
@@ -4258,7 +4258,7 @@
           <p:cNvPr id="2" name="">
             <a:extLst xmlns:a="http://schemas.openxmlformats.org/drawingml/2006/main">
               <a:ext uri="{FF2B5EF4-FFF2-40B4-BE49-F238E27FC236}">
-                <a16:creationId xmlns:a16="http://schemas.microsoft.com/office/drawing/2014/main" id="{91999B09-0EDE-4F42-BCCB-D6892E75160B}"/>
+                <a16:creationId xmlns:a16="http://schemas.microsoft.com/office/drawing/2014/main" id="{620B429D-B4AA-4818-86F2-3D6FD31A92BB}"/>
               </a:ext>
             </a:extLst>
           </p:cNvPr>
@@ -4306,7 +4306,7 @@
                 <a:ea typeface="Malgun Gothic"/>
                 <a:cs typeface="Malgun Gothic"/>
               </a:rPr>
-              <a:t>게시물과 첨부는 업데이트와 롤백 뒤에도 그대로였습니다</a:t>
+              <a:t>운영 게시물과 첨부는 업데이트 전후 그대로입니다</a:t>
             </a:r>
           </a:p>
         </p:txBody>
@@ -4338,7 +4338,7 @@
           <p:cNvPr id="4" name="">
             <a:extLst xmlns:a="http://schemas.openxmlformats.org/drawingml/2006/main">
               <a:ext uri="{FF2B5EF4-FFF2-40B4-BE49-F238E27FC236}">
-                <a16:creationId xmlns:a16="http://schemas.microsoft.com/office/drawing/2014/main" id="{AD952CDB-2980-4368-8DE0-27C10567242F}"/>
+                <a16:creationId xmlns:a16="http://schemas.microsoft.com/office/drawing/2014/main" id="{B41FA536-B84F-4717-95D3-91E612FAA551}"/>
               </a:ext>
             </a:extLst>
           </p:cNvPr>
@@ -4396,7 +4396,7 @@
           <p:cNvPr id="5" name="">
             <a:extLst xmlns:a="http://schemas.openxmlformats.org/drawingml/2006/main">
               <a:ext uri="{FF2B5EF4-FFF2-40B4-BE49-F238E27FC236}">
-                <a16:creationId xmlns:a16="http://schemas.microsoft.com/office/drawing/2014/main" id="{6A34065E-1822-457B-9F07-0F0E5EFBDABC}"/>
+                <a16:creationId xmlns:a16="http://schemas.microsoft.com/office/drawing/2014/main" id="{E12D397B-CCF9-49E0-A6AA-9DEC87DA7961}"/>
               </a:ext>
             </a:extLst>
           </p:cNvPr>
@@ -4429,7 +4429,7 @@
           <p:cNvPr id="6" name="">
             <a:extLst xmlns:a="http://schemas.openxmlformats.org/drawingml/2006/main">
               <a:ext uri="{FF2B5EF4-FFF2-40B4-BE49-F238E27FC236}">
-                <a16:creationId xmlns:a16="http://schemas.microsoft.com/office/drawing/2014/main" id="{76390082-F4FD-49A6-A604-D54578E963A1}"/>
+                <a16:creationId xmlns:a16="http://schemas.microsoft.com/office/drawing/2014/main" id="{149E27A5-F087-4F92-97BC-2CF492B79A03}"/>
               </a:ext>
             </a:extLst>
           </p:cNvPr>
@@ -4487,7 +4487,7 @@
           <p:cNvPr id="7" name="">
             <a:extLst xmlns:a="http://schemas.openxmlformats.org/drawingml/2006/main">
               <a:ext uri="{FF2B5EF4-FFF2-40B4-BE49-F238E27FC236}">
-                <a16:creationId xmlns:a16="http://schemas.microsoft.com/office/drawing/2014/main" id="{8C11A125-A9FF-4949-9006-1C7D944650B6}"/>
+                <a16:creationId xmlns:a16="http://schemas.microsoft.com/office/drawing/2014/main" id="{177FA59A-6C14-4AA0-8654-A8097E5720F4}"/>
               </a:ext>
             </a:extLst>
           </p:cNvPr>
@@ -4520,7 +4520,7 @@
           <p:cNvPr id="8" name="">
             <a:extLst xmlns:a="http://schemas.openxmlformats.org/drawingml/2006/main">
               <a:ext uri="{FF2B5EF4-FFF2-40B4-BE49-F238E27FC236}">
-                <a16:creationId xmlns:a16="http://schemas.microsoft.com/office/drawing/2014/main" id="{94C72C51-FCC7-4A51-B40B-5254E46BA039}"/>
+                <a16:creationId xmlns:a16="http://schemas.microsoft.com/office/drawing/2014/main" id="{0BEBB154-E550-4E5C-9D8E-9093FF98CC81}"/>
               </a:ext>
             </a:extLst>
           </p:cNvPr>
@@ -4568,7 +4568,7 @@
                 <a:ea typeface="Malgun Gothic"/>
                 <a:cs typeface="Malgun Gothic"/>
               </a:rPr>
-              <a:t>기준선</a:t>
+              <a:t>변경 전</a:t>
             </a:r>
           </a:p>
         </p:txBody>
@@ -4578,7 +4578,7 @@
           <p:cNvPr id="9" name="">
             <a:extLst xmlns:a="http://schemas.openxmlformats.org/drawingml/2006/main">
               <a:ext uri="{FF2B5EF4-FFF2-40B4-BE49-F238E27FC236}">
-                <a16:creationId xmlns:a16="http://schemas.microsoft.com/office/drawing/2014/main" id="{BB6D2D93-A50D-4B7B-9C7F-DFE4F07B1F15}"/>
+                <a16:creationId xmlns:a16="http://schemas.microsoft.com/office/drawing/2014/main" id="{6525F585-F7DD-470A-BE65-C225B3EEB045}"/>
               </a:ext>
             </a:extLst>
           </p:cNvPr>
@@ -4611,7 +4611,7 @@
           <p:cNvPr id="10" name="">
             <a:extLst xmlns:a="http://schemas.openxmlformats.org/drawingml/2006/main">
               <a:ext uri="{FF2B5EF4-FFF2-40B4-BE49-F238E27FC236}">
-                <a16:creationId xmlns:a16="http://schemas.microsoft.com/office/drawing/2014/main" id="{FDB462CD-DA6A-4E30-8CA2-18497539950E}"/>
+                <a16:creationId xmlns:a16="http://schemas.microsoft.com/office/drawing/2014/main" id="{7E06E841-B702-4E3B-A06F-B283B22E3929}"/>
               </a:ext>
             </a:extLst>
           </p:cNvPr>
@@ -4659,7 +4659,7 @@
                 <a:ea typeface="Malgun Gothic"/>
                 <a:cs typeface="Malgun Gothic"/>
               </a:rPr>
-              <a:t>1.8.18</a:t>
+              <a:t>변경 후</a:t>
             </a:r>
           </a:p>
         </p:txBody>
@@ -4669,7 +4669,7 @@
           <p:cNvPr id="11" name="">
             <a:extLst xmlns:a="http://schemas.openxmlformats.org/drawingml/2006/main">
               <a:ext uri="{FF2B5EF4-FFF2-40B4-BE49-F238E27FC236}">
-                <a16:creationId xmlns:a16="http://schemas.microsoft.com/office/drawing/2014/main" id="{EC55880E-2E0A-4812-B3F2-ED500BE7825A}"/>
+                <a16:creationId xmlns:a16="http://schemas.microsoft.com/office/drawing/2014/main" id="{4614B158-4660-4997-9064-86A485B7C545}"/>
               </a:ext>
             </a:extLst>
           </p:cNvPr>
@@ -4702,7 +4702,7 @@
           <p:cNvPr id="12" name="">
             <a:extLst xmlns:a="http://schemas.openxmlformats.org/drawingml/2006/main">
               <a:ext uri="{FF2B5EF4-FFF2-40B4-BE49-F238E27FC236}">
-                <a16:creationId xmlns:a16="http://schemas.microsoft.com/office/drawing/2014/main" id="{5136A850-D066-4F93-B1BD-A8311C1644D4}"/>
+                <a16:creationId xmlns:a16="http://schemas.microsoft.com/office/drawing/2014/main" id="{BEA436BB-5343-499A-9B63-DCF354392F10}"/>
               </a:ext>
             </a:extLst>
           </p:cNvPr>
@@ -4750,7 +4750,7 @@
                 <a:ea typeface="Malgun Gothic"/>
                 <a:cs typeface="Malgun Gothic"/>
               </a:rPr>
-              <a:t>롤백</a:t>
+              <a:t>결과</a:t>
             </a:r>
           </a:p>
         </p:txBody>
@@ -4760,7 +4760,7 @@
           <p:cNvPr id="13" name="">
             <a:extLst xmlns:a="http://schemas.openxmlformats.org/drawingml/2006/main">
               <a:ext uri="{FF2B5EF4-FFF2-40B4-BE49-F238E27FC236}">
-                <a16:creationId xmlns:a16="http://schemas.microsoft.com/office/drawing/2014/main" id="{93EA9771-7202-44FA-920C-0642F2C87FDA}"/>
+                <a16:creationId xmlns:a16="http://schemas.microsoft.com/office/drawing/2014/main" id="{D65A19FB-1C73-423E-94DC-DC24CDE5B60B}"/>
               </a:ext>
             </a:extLst>
           </p:cNvPr>
@@ -4793,7 +4793,7 @@
           <p:cNvPr id="14" name="">
             <a:extLst xmlns:a="http://schemas.openxmlformats.org/drawingml/2006/main">
               <a:ext uri="{FF2B5EF4-FFF2-40B4-BE49-F238E27FC236}">
-                <a16:creationId xmlns:a16="http://schemas.microsoft.com/office/drawing/2014/main" id="{ED93D21C-F082-4814-A3E3-D170D4E056B2}"/>
+                <a16:creationId xmlns:a16="http://schemas.microsoft.com/office/drawing/2014/main" id="{2E2C0C0D-714D-4089-9249-7DC41E004CE1}"/>
               </a:ext>
             </a:extLst>
           </p:cNvPr>
@@ -4851,7 +4851,7 @@
           <p:cNvPr id="15" name="">
             <a:extLst xmlns:a="http://schemas.openxmlformats.org/drawingml/2006/main">
               <a:ext uri="{FF2B5EF4-FFF2-40B4-BE49-F238E27FC236}">
-                <a16:creationId xmlns:a16="http://schemas.microsoft.com/office/drawing/2014/main" id="{69392F9A-BC68-4830-89C3-8003FF2A589F}"/>
+                <a16:creationId xmlns:a16="http://schemas.microsoft.com/office/drawing/2014/main" id="{B080BC55-073C-48A5-AE91-553900351708}"/>
               </a:ext>
             </a:extLst>
           </p:cNvPr>
@@ -4884,7 +4884,7 @@
           <p:cNvPr id="16" name="">
             <a:extLst xmlns:a="http://schemas.openxmlformats.org/drawingml/2006/main">
               <a:ext uri="{FF2B5EF4-FFF2-40B4-BE49-F238E27FC236}">
-                <a16:creationId xmlns:a16="http://schemas.microsoft.com/office/drawing/2014/main" id="{637DD38A-F531-413B-97E6-70C03DA8DE0D}"/>
+                <a16:creationId xmlns:a16="http://schemas.microsoft.com/office/drawing/2014/main" id="{D2AF8281-43AE-4E2B-9AD4-5A19A0F2ADA9}"/>
               </a:ext>
             </a:extLst>
           </p:cNvPr>
@@ -4942,7 +4942,7 @@
           <p:cNvPr id="17" name="">
             <a:extLst xmlns:a="http://schemas.openxmlformats.org/drawingml/2006/main">
               <a:ext uri="{FF2B5EF4-FFF2-40B4-BE49-F238E27FC236}">
-                <a16:creationId xmlns:a16="http://schemas.microsoft.com/office/drawing/2014/main" id="{A26C9187-DE8F-4A32-BB51-BFAC46034636}"/>
+                <a16:creationId xmlns:a16="http://schemas.microsoft.com/office/drawing/2014/main" id="{EB271897-5239-486C-8B51-B0B829A2AC82}"/>
               </a:ext>
             </a:extLst>
           </p:cNvPr>
@@ -4975,7 +4975,7 @@
           <p:cNvPr id="18" name="">
             <a:extLst xmlns:a="http://schemas.openxmlformats.org/drawingml/2006/main">
               <a:ext uri="{FF2B5EF4-FFF2-40B4-BE49-F238E27FC236}">
-                <a16:creationId xmlns:a16="http://schemas.microsoft.com/office/drawing/2014/main" id="{E9B51FCA-3976-475C-B2ED-07D8C61D0DFD}"/>
+                <a16:creationId xmlns:a16="http://schemas.microsoft.com/office/drawing/2014/main" id="{BB169E87-29DA-49E1-AA48-4269CC9BAFA6}"/>
               </a:ext>
             </a:extLst>
           </p:cNvPr>
@@ -5033,7 +5033,7 @@
           <p:cNvPr id="19" name="">
             <a:extLst xmlns:a="http://schemas.openxmlformats.org/drawingml/2006/main">
               <a:ext uri="{FF2B5EF4-FFF2-40B4-BE49-F238E27FC236}">
-                <a16:creationId xmlns:a16="http://schemas.microsoft.com/office/drawing/2014/main" id="{32CC04C0-288F-420E-A693-18C9FBBF854E}"/>
+                <a16:creationId xmlns:a16="http://schemas.microsoft.com/office/drawing/2014/main" id="{973F227B-0678-4350-8AC7-73A9C3F38817}"/>
               </a:ext>
             </a:extLst>
           </p:cNvPr>
@@ -5066,7 +5066,7 @@
           <p:cNvPr id="20" name="">
             <a:extLst xmlns:a="http://schemas.openxmlformats.org/drawingml/2006/main">
               <a:ext uri="{FF2B5EF4-FFF2-40B4-BE49-F238E27FC236}">
-                <a16:creationId xmlns:a16="http://schemas.microsoft.com/office/drawing/2014/main" id="{744CF2F1-7DA4-4FBC-95A1-2237E3D58E38}"/>
+                <a16:creationId xmlns:a16="http://schemas.microsoft.com/office/drawing/2014/main" id="{CCF32636-B0BD-4449-9767-2CAF00834673}"/>
               </a:ext>
             </a:extLst>
           </p:cNvPr>
@@ -5114,7 +5114,7 @@
                 <a:ea typeface="Malgun Gothic"/>
                 <a:cs typeface="Malgun Gothic"/>
               </a:rPr>
-              <a:t>39</a:t>
+              <a:t>일치</a:t>
             </a:r>
           </a:p>
         </p:txBody>
@@ -5124,7 +5124,7 @@
           <p:cNvPr id="21" name="">
             <a:extLst xmlns:a="http://schemas.openxmlformats.org/drawingml/2006/main">
               <a:ext uri="{FF2B5EF4-FFF2-40B4-BE49-F238E27FC236}">
-                <a16:creationId xmlns:a16="http://schemas.microsoft.com/office/drawing/2014/main" id="{E1BB92B9-935F-4E6C-B1BA-CB294EF5FF4C}"/>
+                <a16:creationId xmlns:a16="http://schemas.microsoft.com/office/drawing/2014/main" id="{25C68164-D9D6-4AAE-A220-EE2E6E381526}"/>
               </a:ext>
             </a:extLst>
           </p:cNvPr>
@@ -5157,7 +5157,7 @@
           <p:cNvPr id="22" name="">
             <a:extLst xmlns:a="http://schemas.openxmlformats.org/drawingml/2006/main">
               <a:ext uri="{FF2B5EF4-FFF2-40B4-BE49-F238E27FC236}">
-                <a16:creationId xmlns:a16="http://schemas.microsoft.com/office/drawing/2014/main" id="{0EE49144-29E9-4EAF-894C-0EB1C15F7022}"/>
+                <a16:creationId xmlns:a16="http://schemas.microsoft.com/office/drawing/2014/main" id="{60BCB5E6-DAFC-48A6-9B47-DB9E3A3FCA54}"/>
               </a:ext>
             </a:extLst>
           </p:cNvPr>
@@ -5215,7 +5215,7 @@
           <p:cNvPr id="23" name="">
             <a:extLst xmlns:a="http://schemas.openxmlformats.org/drawingml/2006/main">
               <a:ext uri="{FF2B5EF4-FFF2-40B4-BE49-F238E27FC236}">
-                <a16:creationId xmlns:a16="http://schemas.microsoft.com/office/drawing/2014/main" id="{E785FEEA-3DB6-4507-BE19-5E06281B2F3E}"/>
+                <a16:creationId xmlns:a16="http://schemas.microsoft.com/office/drawing/2014/main" id="{ED6C10DE-10EC-4E83-B5CF-455DABAFEEFD}"/>
               </a:ext>
             </a:extLst>
           </p:cNvPr>
@@ -5248,7 +5248,7 @@
           <p:cNvPr id="24" name="">
             <a:extLst xmlns:a="http://schemas.openxmlformats.org/drawingml/2006/main">
               <a:ext uri="{FF2B5EF4-FFF2-40B4-BE49-F238E27FC236}">
-                <a16:creationId xmlns:a16="http://schemas.microsoft.com/office/drawing/2014/main" id="{4EEA7583-8A20-4F1C-968B-5ED0949E3769}"/>
+                <a16:creationId xmlns:a16="http://schemas.microsoft.com/office/drawing/2014/main" id="{9B52E4E7-8617-42D2-AC59-7EC8544803E4}"/>
               </a:ext>
             </a:extLst>
           </p:cNvPr>
@@ -5296,7 +5296,7 @@
                 <a:ea typeface="Malgun Gothic"/>
                 <a:cs typeface="Malgun Gothic"/>
               </a:rPr>
-              <a:t>117</a:t>
+              <a:t>120</a:t>
             </a:r>
           </a:p>
         </p:txBody>
@@ -5306,7 +5306,7 @@
           <p:cNvPr id="25" name="">
             <a:extLst xmlns:a="http://schemas.openxmlformats.org/drawingml/2006/main">
               <a:ext uri="{FF2B5EF4-FFF2-40B4-BE49-F238E27FC236}">
-                <a16:creationId xmlns:a16="http://schemas.microsoft.com/office/drawing/2014/main" id="{5F6D2140-CECF-47B9-9195-6A0DF252B18B}"/>
+                <a16:creationId xmlns:a16="http://schemas.microsoft.com/office/drawing/2014/main" id="{2FAFC79D-60AC-4A85-918D-F39EBEAD6E58}"/>
               </a:ext>
             </a:extLst>
           </p:cNvPr>
@@ -5339,7 +5339,7 @@
           <p:cNvPr id="26" name="">
             <a:extLst xmlns:a="http://schemas.openxmlformats.org/drawingml/2006/main">
               <a:ext uri="{FF2B5EF4-FFF2-40B4-BE49-F238E27FC236}">
-                <a16:creationId xmlns:a16="http://schemas.microsoft.com/office/drawing/2014/main" id="{4621D793-74F4-4E0A-9554-C80BE2989166}"/>
+                <a16:creationId xmlns:a16="http://schemas.microsoft.com/office/drawing/2014/main" id="{EAE17C69-6FBA-4C13-A32C-B4E585AD76B5}"/>
               </a:ext>
             </a:extLst>
           </p:cNvPr>
@@ -5387,7 +5387,7 @@
                 <a:ea typeface="Malgun Gothic"/>
                 <a:cs typeface="Malgun Gothic"/>
               </a:rPr>
-              <a:t>117</a:t>
+              <a:t>120</a:t>
             </a:r>
           </a:p>
         </p:txBody>
@@ -5397,7 +5397,7 @@
           <p:cNvPr id="27" name="">
             <a:extLst xmlns:a="http://schemas.openxmlformats.org/drawingml/2006/main">
               <a:ext uri="{FF2B5EF4-FFF2-40B4-BE49-F238E27FC236}">
-                <a16:creationId xmlns:a16="http://schemas.microsoft.com/office/drawing/2014/main" id="{4F16E653-FDD4-4BF8-B85A-648F73075C45}"/>
+                <a16:creationId xmlns:a16="http://schemas.microsoft.com/office/drawing/2014/main" id="{5E86B0BD-DACE-4B7E-8306-F467311D2A62}"/>
               </a:ext>
             </a:extLst>
           </p:cNvPr>
@@ -5430,7 +5430,7 @@
           <p:cNvPr id="28" name="">
             <a:extLst xmlns:a="http://schemas.openxmlformats.org/drawingml/2006/main">
               <a:ext uri="{FF2B5EF4-FFF2-40B4-BE49-F238E27FC236}">
-                <a16:creationId xmlns:a16="http://schemas.microsoft.com/office/drawing/2014/main" id="{B881D435-A223-42AC-8C00-7A7690BEC222}"/>
+                <a16:creationId xmlns:a16="http://schemas.microsoft.com/office/drawing/2014/main" id="{8E4262D9-C1B4-4441-B404-3536A43BBCF3}"/>
               </a:ext>
             </a:extLst>
           </p:cNvPr>
@@ -5478,7 +5478,7 @@
                 <a:ea typeface="Malgun Gothic"/>
                 <a:cs typeface="Malgun Gothic"/>
               </a:rPr>
-              <a:t>117</a:t>
+              <a:t>일치</a:t>
             </a:r>
           </a:p>
         </p:txBody>
@@ -5488,7 +5488,7 @@
           <p:cNvPr id="29" name="">
             <a:extLst xmlns:a="http://schemas.openxmlformats.org/drawingml/2006/main">
               <a:ext uri="{FF2B5EF4-FFF2-40B4-BE49-F238E27FC236}">
-                <a16:creationId xmlns:a16="http://schemas.microsoft.com/office/drawing/2014/main" id="{B141D672-E32C-438D-BEB1-2D219A64D33B}"/>
+                <a16:creationId xmlns:a16="http://schemas.microsoft.com/office/drawing/2014/main" id="{BC66AC32-262C-4C41-95EC-28ED53035394}"/>
               </a:ext>
             </a:extLst>
           </p:cNvPr>
@@ -5521,7 +5521,7 @@
           <p:cNvPr id="30" name="">
             <a:extLst xmlns:a="http://schemas.openxmlformats.org/drawingml/2006/main">
               <a:ext uri="{FF2B5EF4-FFF2-40B4-BE49-F238E27FC236}">
-                <a16:creationId xmlns:a16="http://schemas.microsoft.com/office/drawing/2014/main" id="{E63D736E-C2EC-421C-8B33-8C262A0A3233}"/>
+                <a16:creationId xmlns:a16="http://schemas.microsoft.com/office/drawing/2014/main" id="{4F28ACC4-E813-4D2E-A977-170B0AA7CBF1}"/>
               </a:ext>
             </a:extLst>
           </p:cNvPr>
@@ -5579,7 +5579,7 @@
           <p:cNvPr id="31" name="">
             <a:extLst xmlns:a="http://schemas.openxmlformats.org/drawingml/2006/main">
               <a:ext uri="{FF2B5EF4-FFF2-40B4-BE49-F238E27FC236}">
-                <a16:creationId xmlns:a16="http://schemas.microsoft.com/office/drawing/2014/main" id="{7A1B54D4-9725-4AF0-9B0E-66AE68BC1B52}"/>
+                <a16:creationId xmlns:a16="http://schemas.microsoft.com/office/drawing/2014/main" id="{DFA838B1-5FDD-4BA7-B1FE-2D3DFA13F65F}"/>
               </a:ext>
             </a:extLst>
           </p:cNvPr>
@@ -5612,7 +5612,7 @@
           <p:cNvPr id="32" name="">
             <a:extLst xmlns:a="http://schemas.openxmlformats.org/drawingml/2006/main">
               <a:ext uri="{FF2B5EF4-FFF2-40B4-BE49-F238E27FC236}">
-                <a16:creationId xmlns:a16="http://schemas.microsoft.com/office/drawing/2014/main" id="{D8535CE0-8F7E-46E2-975B-35BE3BCDC462}"/>
+                <a16:creationId xmlns:a16="http://schemas.microsoft.com/office/drawing/2014/main" id="{570AD08D-E92D-4132-98A9-D0841E3A8D84}"/>
               </a:ext>
             </a:extLst>
           </p:cNvPr>
@@ -5660,7 +5660,7 @@
                 <a:ea typeface="Malgun Gothic"/>
                 <a:cs typeface="Malgun Gothic"/>
               </a:rPr>
-              <a:t>305</a:t>
+              <a:t>320</a:t>
             </a:r>
           </a:p>
         </p:txBody>
@@ -5670,7 +5670,7 @@
           <p:cNvPr id="33" name="">
             <a:extLst xmlns:a="http://schemas.openxmlformats.org/drawingml/2006/main">
               <a:ext uri="{FF2B5EF4-FFF2-40B4-BE49-F238E27FC236}">
-                <a16:creationId xmlns:a16="http://schemas.microsoft.com/office/drawing/2014/main" id="{FF6E3852-C121-4F93-B40B-13F7374D8537}"/>
+                <a16:creationId xmlns:a16="http://schemas.microsoft.com/office/drawing/2014/main" id="{4E87E3AE-7B47-4FD4-A91C-0AC790A66C11}"/>
               </a:ext>
             </a:extLst>
           </p:cNvPr>
@@ -5703,7 +5703,7 @@
           <p:cNvPr id="34" name="">
             <a:extLst xmlns:a="http://schemas.openxmlformats.org/drawingml/2006/main">
               <a:ext uri="{FF2B5EF4-FFF2-40B4-BE49-F238E27FC236}">
-                <a16:creationId xmlns:a16="http://schemas.microsoft.com/office/drawing/2014/main" id="{63F11517-D4A5-4F68-9BF6-A91E401EECF1}"/>
+                <a16:creationId xmlns:a16="http://schemas.microsoft.com/office/drawing/2014/main" id="{83AB5AFB-912D-4312-A0B3-2A1C3C46DC48}"/>
               </a:ext>
             </a:extLst>
           </p:cNvPr>
@@ -5751,7 +5751,7 @@
                 <a:ea typeface="Malgun Gothic"/>
                 <a:cs typeface="Malgun Gothic"/>
               </a:rPr>
-              <a:t>305</a:t>
+              <a:t>320</a:t>
             </a:r>
           </a:p>
         </p:txBody>
@@ -5761,7 +5761,7 @@
           <p:cNvPr id="35" name="">
             <a:extLst xmlns:a="http://schemas.openxmlformats.org/drawingml/2006/main">
               <a:ext uri="{FF2B5EF4-FFF2-40B4-BE49-F238E27FC236}">
-                <a16:creationId xmlns:a16="http://schemas.microsoft.com/office/drawing/2014/main" id="{1789C3A5-3F91-4E6D-BBA8-1690FDE4B5C1}"/>
+                <a16:creationId xmlns:a16="http://schemas.microsoft.com/office/drawing/2014/main" id="{36D34F4A-69FA-4D66-B6A0-DB96BC8BEDE0}"/>
               </a:ext>
             </a:extLst>
           </p:cNvPr>
@@ -5794,7 +5794,7 @@
           <p:cNvPr id="36" name="">
             <a:extLst xmlns:a="http://schemas.openxmlformats.org/drawingml/2006/main">
               <a:ext uri="{FF2B5EF4-FFF2-40B4-BE49-F238E27FC236}">
-                <a16:creationId xmlns:a16="http://schemas.microsoft.com/office/drawing/2014/main" id="{EEBEC28C-75B0-453D-B8F7-CE4D3D4F79E3}"/>
+                <a16:creationId xmlns:a16="http://schemas.microsoft.com/office/drawing/2014/main" id="{5D6E106A-7ABE-4108-8E23-ED148D0F9A4E}"/>
               </a:ext>
             </a:extLst>
           </p:cNvPr>
@@ -5842,7 +5842,7 @@
                 <a:ea typeface="Malgun Gothic"/>
                 <a:cs typeface="Malgun Gothic"/>
               </a:rPr>
-              <a:t>305</a:t>
+              <a:t>일치</a:t>
             </a:r>
           </a:p>
         </p:txBody>
@@ -5852,7 +5852,7 @@
           <p:cNvPr id="37" name="">
             <a:extLst xmlns:a="http://schemas.openxmlformats.org/drawingml/2006/main">
               <a:ext uri="{FF2B5EF4-FFF2-40B4-BE49-F238E27FC236}">
-                <a16:creationId xmlns:a16="http://schemas.microsoft.com/office/drawing/2014/main" id="{0FBC75B8-6ED3-45CF-B684-1E33263AE4E6}"/>
+                <a16:creationId xmlns:a16="http://schemas.microsoft.com/office/drawing/2014/main" id="{F1BF22BE-86C7-428D-AC05-803653AFA435}"/>
               </a:ext>
             </a:extLst>
           </p:cNvPr>
@@ -5885,7 +5885,7 @@
           <p:cNvPr id="38" name="">
             <a:extLst xmlns:a="http://schemas.openxmlformats.org/drawingml/2006/main">
               <a:ext uri="{FF2B5EF4-FFF2-40B4-BE49-F238E27FC236}">
-                <a16:creationId xmlns:a16="http://schemas.microsoft.com/office/drawing/2014/main" id="{0906F8C6-5154-4C64-A19C-39085F2D74CF}"/>
+                <a16:creationId xmlns:a16="http://schemas.microsoft.com/office/drawing/2014/main" id="{17A7ABDE-96C7-4E52-B516-8AC6D4A16EF1}"/>
               </a:ext>
             </a:extLst>
           </p:cNvPr>
@@ -5943,7 +5943,7 @@
           <p:cNvPr id="39" name="">
             <a:extLst xmlns:a="http://schemas.openxmlformats.org/drawingml/2006/main">
               <a:ext uri="{FF2B5EF4-FFF2-40B4-BE49-F238E27FC236}">
-                <a16:creationId xmlns:a16="http://schemas.microsoft.com/office/drawing/2014/main" id="{199B403F-DB99-4418-9DE2-FECC0E6CDD64}"/>
+                <a16:creationId xmlns:a16="http://schemas.microsoft.com/office/drawing/2014/main" id="{AF5C5B11-F81E-4014-9DB8-146190CBA3FA}"/>
               </a:ext>
             </a:extLst>
           </p:cNvPr>
@@ -5976,7 +5976,7 @@
           <p:cNvPr id="40" name="">
             <a:extLst xmlns:a="http://schemas.openxmlformats.org/drawingml/2006/main">
               <a:ext uri="{FF2B5EF4-FFF2-40B4-BE49-F238E27FC236}">
-                <a16:creationId xmlns:a16="http://schemas.microsoft.com/office/drawing/2014/main" id="{4F7349ED-1C1C-4261-B3A6-F65CD39B2593}"/>
+                <a16:creationId xmlns:a16="http://schemas.microsoft.com/office/drawing/2014/main" id="{48D45794-6B9A-46ED-A1E4-82828B77CCFC}"/>
               </a:ext>
             </a:extLst>
           </p:cNvPr>
@@ -6024,7 +6024,7 @@
                 <a:ea typeface="Malgun Gothic"/>
                 <a:cs typeface="Malgun Gothic"/>
               </a:rPr>
-              <a:t>114</a:t>
+              <a:t>115</a:t>
             </a:r>
           </a:p>
         </p:txBody>
@@ -6034,7 +6034,7 @@
           <p:cNvPr id="41" name="">
             <a:extLst xmlns:a="http://schemas.openxmlformats.org/drawingml/2006/main">
               <a:ext uri="{FF2B5EF4-FFF2-40B4-BE49-F238E27FC236}">
-                <a16:creationId xmlns:a16="http://schemas.microsoft.com/office/drawing/2014/main" id="{E2EEC385-DBA2-4677-8FD1-E071FF69E3F8}"/>
+                <a16:creationId xmlns:a16="http://schemas.microsoft.com/office/drawing/2014/main" id="{9A8155A6-FCA1-4B47-B110-4AB657D850E1}"/>
               </a:ext>
             </a:extLst>
           </p:cNvPr>
@@ -6067,7 +6067,7 @@
           <p:cNvPr id="42" name="">
             <a:extLst xmlns:a="http://schemas.openxmlformats.org/drawingml/2006/main">
               <a:ext uri="{FF2B5EF4-FFF2-40B4-BE49-F238E27FC236}">
-                <a16:creationId xmlns:a16="http://schemas.microsoft.com/office/drawing/2014/main" id="{14FC7228-602B-48AA-B815-97C86D51EE7E}"/>
+                <a16:creationId xmlns:a16="http://schemas.microsoft.com/office/drawing/2014/main" id="{BF0B2690-6C5A-4927-8E74-D8F6D2BBF7AD}"/>
               </a:ext>
             </a:extLst>
           </p:cNvPr>
@@ -6115,7 +6115,7 @@
                 <a:ea typeface="Malgun Gothic"/>
                 <a:cs typeface="Malgun Gothic"/>
               </a:rPr>
-              <a:t>114</a:t>
+              <a:t>115</a:t>
             </a:r>
           </a:p>
         </p:txBody>
@@ -6125,7 +6125,7 @@
           <p:cNvPr id="43" name="">
             <a:extLst xmlns:a="http://schemas.openxmlformats.org/drawingml/2006/main">
               <a:ext uri="{FF2B5EF4-FFF2-40B4-BE49-F238E27FC236}">
-                <a16:creationId xmlns:a16="http://schemas.microsoft.com/office/drawing/2014/main" id="{284F4590-41DA-4986-ACEA-A1DC05C9A95F}"/>
+                <a16:creationId xmlns:a16="http://schemas.microsoft.com/office/drawing/2014/main" id="{B3546F34-9873-4B7B-B662-0BA28434C312}"/>
               </a:ext>
             </a:extLst>
           </p:cNvPr>
@@ -6158,7 +6158,7 @@
           <p:cNvPr id="44" name="">
             <a:extLst xmlns:a="http://schemas.openxmlformats.org/drawingml/2006/main">
               <a:ext uri="{FF2B5EF4-FFF2-40B4-BE49-F238E27FC236}">
-                <a16:creationId xmlns:a16="http://schemas.microsoft.com/office/drawing/2014/main" id="{B7672B69-04B0-445A-9FEC-FE6806DA896B}"/>
+                <a16:creationId xmlns:a16="http://schemas.microsoft.com/office/drawing/2014/main" id="{A9DC648E-44F0-420B-BBF2-F7B3BA50F8ED}"/>
               </a:ext>
             </a:extLst>
           </p:cNvPr>
@@ -6206,7 +6206,7 @@
                 <a:ea typeface="Malgun Gothic"/>
                 <a:cs typeface="Malgun Gothic"/>
               </a:rPr>
-              <a:t>114</a:t>
+              <a:t>일치</a:t>
             </a:r>
           </a:p>
         </p:txBody>
@@ -6216,7 +6216,7 @@
           <p:cNvPr id="45" name="">
             <a:extLst xmlns:a="http://schemas.openxmlformats.org/drawingml/2006/main">
               <a:ext uri="{FF2B5EF4-FFF2-40B4-BE49-F238E27FC236}">
-                <a16:creationId xmlns:a16="http://schemas.microsoft.com/office/drawing/2014/main" id="{F02B00BA-76F9-4F5C-9E82-6837439B4853}"/>
+                <a16:creationId xmlns:a16="http://schemas.microsoft.com/office/drawing/2014/main" id="{0BE832E6-94C1-435E-8F7A-3F96BC382245}"/>
               </a:ext>
             </a:extLst>
           </p:cNvPr>
@@ -6249,7 +6249,7 @@
           <p:cNvPr id="46" name="">
             <a:extLst xmlns:a="http://schemas.openxmlformats.org/drawingml/2006/main">
               <a:ext uri="{FF2B5EF4-FFF2-40B4-BE49-F238E27FC236}">
-                <a16:creationId xmlns:a16="http://schemas.microsoft.com/office/drawing/2014/main" id="{1E4A8BFE-38A3-4D7E-9967-923158929AE9}"/>
+                <a16:creationId xmlns:a16="http://schemas.microsoft.com/office/drawing/2014/main" id="{6CEE2E59-0684-4F6E-AA49-52218EDF419A}"/>
               </a:ext>
             </a:extLst>
           </p:cNvPr>
@@ -6307,7 +6307,7 @@
           <p:cNvPr id="47" name="">
             <a:extLst xmlns:a="http://schemas.openxmlformats.org/drawingml/2006/main">
               <a:ext uri="{FF2B5EF4-FFF2-40B4-BE49-F238E27FC236}">
-                <a16:creationId xmlns:a16="http://schemas.microsoft.com/office/drawing/2014/main" id="{D6857D25-7C75-4D71-AD6B-2A76AD2050AF}"/>
+                <a16:creationId xmlns:a16="http://schemas.microsoft.com/office/drawing/2014/main" id="{34697884-FE30-4949-8996-A1AA138F71A0}"/>
               </a:ext>
             </a:extLst>
           </p:cNvPr>
@@ -6340,7 +6340,7 @@
           <p:cNvPr id="48" name="">
             <a:extLst xmlns:a="http://schemas.openxmlformats.org/drawingml/2006/main">
               <a:ext uri="{FF2B5EF4-FFF2-40B4-BE49-F238E27FC236}">
-                <a16:creationId xmlns:a16="http://schemas.microsoft.com/office/drawing/2014/main" id="{7195A6E1-4F3F-46EB-B923-09DCB5E9532B}"/>
+                <a16:creationId xmlns:a16="http://schemas.microsoft.com/office/drawing/2014/main" id="{B9FB8612-2FD0-46F3-BE44-3A9EB06F878E}"/>
               </a:ext>
             </a:extLst>
           </p:cNvPr>
@@ -6388,7 +6388,7 @@
                 <a:ea typeface="Malgun Gothic"/>
                 <a:cs typeface="Malgun Gothic"/>
               </a:rPr>
-              <a:t>25,939,695 B</a:t>
+              <a:t>26,060,120 B</a:t>
             </a:r>
           </a:p>
         </p:txBody>
@@ -6398,7 +6398,7 @@
           <p:cNvPr id="49" name="">
             <a:extLst xmlns:a="http://schemas.openxmlformats.org/drawingml/2006/main">
               <a:ext uri="{FF2B5EF4-FFF2-40B4-BE49-F238E27FC236}">
-                <a16:creationId xmlns:a16="http://schemas.microsoft.com/office/drawing/2014/main" id="{E7FC8411-703F-4BA7-BEEC-21EEBBFEA057}"/>
+                <a16:creationId xmlns:a16="http://schemas.microsoft.com/office/drawing/2014/main" id="{33FC5C7D-DBF7-40AD-A472-3B1C5CE5B48A}"/>
               </a:ext>
             </a:extLst>
           </p:cNvPr>
@@ -6431,7 +6431,7 @@
           <p:cNvPr id="50" name="">
             <a:extLst xmlns:a="http://schemas.openxmlformats.org/drawingml/2006/main">
               <a:ext uri="{FF2B5EF4-FFF2-40B4-BE49-F238E27FC236}">
-                <a16:creationId xmlns:a16="http://schemas.microsoft.com/office/drawing/2014/main" id="{6CA5DE43-C0F1-4FC6-ADD2-9BD275819FF6}"/>
+                <a16:creationId xmlns:a16="http://schemas.microsoft.com/office/drawing/2014/main" id="{43718785-6083-4A6D-8BAA-2DF880396052}"/>
               </a:ext>
             </a:extLst>
           </p:cNvPr>
@@ -6479,7 +6479,7 @@
                 <a:ea typeface="Malgun Gothic"/>
                 <a:cs typeface="Malgun Gothic"/>
               </a:rPr>
-              <a:t>동일</a:t>
+              <a:t>26,060,120 B</a:t>
             </a:r>
           </a:p>
         </p:txBody>
@@ -6489,7 +6489,7 @@
           <p:cNvPr id="51" name="">
             <a:extLst xmlns:a="http://schemas.openxmlformats.org/drawingml/2006/main">
               <a:ext uri="{FF2B5EF4-FFF2-40B4-BE49-F238E27FC236}">
-                <a16:creationId xmlns:a16="http://schemas.microsoft.com/office/drawing/2014/main" id="{0BE74A9F-0B15-4C9D-BA9B-0847869B609D}"/>
+                <a16:creationId xmlns:a16="http://schemas.microsoft.com/office/drawing/2014/main" id="{647EB4C5-19F0-4048-B957-388ADC77C4DD}"/>
               </a:ext>
             </a:extLst>
           </p:cNvPr>
@@ -6522,7 +6522,7 @@
           <p:cNvPr id="52" name="">
             <a:extLst xmlns:a="http://schemas.openxmlformats.org/drawingml/2006/main">
               <a:ext uri="{FF2B5EF4-FFF2-40B4-BE49-F238E27FC236}">
-                <a16:creationId xmlns:a16="http://schemas.microsoft.com/office/drawing/2014/main" id="{C00E1B61-2F88-40D7-B0CB-8454F89E6FEC}"/>
+                <a16:creationId xmlns:a16="http://schemas.microsoft.com/office/drawing/2014/main" id="{14658714-44CA-4C00-8C65-022DE16D110F}"/>
               </a:ext>
             </a:extLst>
           </p:cNvPr>
@@ -6570,7 +6570,7 @@
                 <a:ea typeface="Malgun Gothic"/>
                 <a:cs typeface="Malgun Gothic"/>
               </a:rPr>
-              <a:t>동일</a:t>
+              <a:t>일치</a:t>
             </a:r>
           </a:p>
         </p:txBody>
@@ -6580,7 +6580,7 @@
           <p:cNvPr id="53" name="">
             <a:extLst xmlns:a="http://schemas.openxmlformats.org/drawingml/2006/main">
               <a:ext uri="{FF2B5EF4-FFF2-40B4-BE49-F238E27FC236}">
-                <a16:creationId xmlns:a16="http://schemas.microsoft.com/office/drawing/2014/main" id="{BE7BCE60-FD6A-4E28-9DC7-C6C893555DD7}"/>
+                <a16:creationId xmlns:a16="http://schemas.microsoft.com/office/drawing/2014/main" id="{45A1C3AE-C4FB-4049-A9ED-F4DAFC84902A}"/>
               </a:ext>
             </a:extLst>
           </p:cNvPr>
@@ -6613,7 +6613,7 @@
           <p:cNvPr id="54" name="">
             <a:extLst xmlns:a="http://schemas.openxmlformats.org/drawingml/2006/main">
               <a:ext uri="{FF2B5EF4-FFF2-40B4-BE49-F238E27FC236}">
-                <a16:creationId xmlns:a16="http://schemas.microsoft.com/office/drawing/2014/main" id="{3FA2D4B6-738B-4C14-90C7-3798561F2EF9}"/>
+                <a16:creationId xmlns:a16="http://schemas.microsoft.com/office/drawing/2014/main" id="{0B198D38-AB99-4147-B29F-02E5EBA647ED}"/>
               </a:ext>
             </a:extLst>
           </p:cNvPr>
@@ -6671,7 +6671,7 @@
           <p:cNvPr id="55" name="">
             <a:extLst xmlns:a="http://schemas.openxmlformats.org/drawingml/2006/main">
               <a:ext uri="{FF2B5EF4-FFF2-40B4-BE49-F238E27FC236}">
-                <a16:creationId xmlns:a16="http://schemas.microsoft.com/office/drawing/2014/main" id="{614F6AA7-BBF4-4973-AB48-A7AF7EDC03DA}"/>
+                <a16:creationId xmlns:a16="http://schemas.microsoft.com/office/drawing/2014/main" id="{11CE24A3-102C-4BF0-B249-54F1344052E6}"/>
               </a:ext>
             </a:extLst>
           </p:cNvPr>
@@ -6704,7 +6704,7 @@
           <p:cNvPr id="56" name="">
             <a:extLst xmlns:a="http://schemas.openxmlformats.org/drawingml/2006/main">
               <a:ext uri="{FF2B5EF4-FFF2-40B4-BE49-F238E27FC236}">
-                <a16:creationId xmlns:a16="http://schemas.microsoft.com/office/drawing/2014/main" id="{6290CB07-E0DC-46ED-B3C1-6DAB1AD7B60B}"/>
+                <a16:creationId xmlns:a16="http://schemas.microsoft.com/office/drawing/2014/main" id="{F4F7856E-3B8C-4D64-8746-F06B7DBCADDF}"/>
               </a:ext>
             </a:extLst>
           </p:cNvPr>
@@ -6752,7 +6752,7 @@
                 <a:ea typeface="Malgun Gothic"/>
                 <a:cs typeface="Malgun Gothic"/>
               </a:rPr>
-              <a:t>19cdf526…a97c</a:t>
+              <a:t>35cbac9f…ff50</a:t>
             </a:r>
           </a:p>
         </p:txBody>
@@ -6762,7 +6762,7 @@
           <p:cNvPr id="57" name="">
             <a:extLst xmlns:a="http://schemas.openxmlformats.org/drawingml/2006/main">
               <a:ext uri="{FF2B5EF4-FFF2-40B4-BE49-F238E27FC236}">
-                <a16:creationId xmlns:a16="http://schemas.microsoft.com/office/drawing/2014/main" id="{EEC5DE8F-DFB5-46F6-99B7-4CB40A842B56}"/>
+                <a16:creationId xmlns:a16="http://schemas.microsoft.com/office/drawing/2014/main" id="{56638A8A-DBF6-4F8D-BCD6-3A9145EC50E6}"/>
               </a:ext>
             </a:extLst>
           </p:cNvPr>
@@ -6795,7 +6795,7 @@
           <p:cNvPr id="58" name="">
             <a:extLst xmlns:a="http://schemas.openxmlformats.org/drawingml/2006/main">
               <a:ext uri="{FF2B5EF4-FFF2-40B4-BE49-F238E27FC236}">
-                <a16:creationId xmlns:a16="http://schemas.microsoft.com/office/drawing/2014/main" id="{9C4145AE-E072-440E-90D1-954D72BF6485}"/>
+                <a16:creationId xmlns:a16="http://schemas.microsoft.com/office/drawing/2014/main" id="{53F885BC-F129-4914-887E-8A62CF866D3A}"/>
               </a:ext>
             </a:extLst>
           </p:cNvPr>
@@ -6853,7 +6853,7 @@
           <p:cNvPr id="59" name="">
             <a:extLst xmlns:a="http://schemas.openxmlformats.org/drawingml/2006/main">
               <a:ext uri="{FF2B5EF4-FFF2-40B4-BE49-F238E27FC236}">
-                <a16:creationId xmlns:a16="http://schemas.microsoft.com/office/drawing/2014/main" id="{36DFCC5B-D287-4000-BFB3-34EEB1BB149E}"/>
+                <a16:creationId xmlns:a16="http://schemas.microsoft.com/office/drawing/2014/main" id="{324DD48C-A9BD-45DD-A102-76F00BF72AD6}"/>
               </a:ext>
             </a:extLst>
           </p:cNvPr>
@@ -6886,7 +6886,7 @@
           <p:cNvPr id="60" name="">
             <a:extLst xmlns:a="http://schemas.openxmlformats.org/drawingml/2006/main">
               <a:ext uri="{FF2B5EF4-FFF2-40B4-BE49-F238E27FC236}">
-                <a16:creationId xmlns:a16="http://schemas.microsoft.com/office/drawing/2014/main" id="{94AD5A63-F316-4AF1-8937-A3CF2CD5F949}"/>
+                <a16:creationId xmlns:a16="http://schemas.microsoft.com/office/drawing/2014/main" id="{547E3EC7-AA73-4B92-8B6C-EECA9F756CDD}"/>
               </a:ext>
             </a:extLst>
           </p:cNvPr>
@@ -6934,7 +6934,7 @@
                 <a:ea typeface="Malgun Gothic"/>
                 <a:cs typeface="Malgun Gothic"/>
               </a:rPr>
-              <a:t>동일</a:t>
+              <a:t>일치</a:t>
             </a:r>
           </a:p>
         </p:txBody>
@@ -6944,7 +6944,7 @@
           <p:cNvPr id="61" name="">
             <a:extLst xmlns:a="http://schemas.openxmlformats.org/drawingml/2006/main">
               <a:ext uri="{FF2B5EF4-FFF2-40B4-BE49-F238E27FC236}">
-                <a16:creationId xmlns:a16="http://schemas.microsoft.com/office/drawing/2014/main" id="{ADB39761-CB2A-43E2-8D0E-62DD998C868C}"/>
+                <a16:creationId xmlns:a16="http://schemas.microsoft.com/office/drawing/2014/main" id="{861A334B-992E-4A16-8680-074AA57A7595}"/>
               </a:ext>
             </a:extLst>
           </p:cNvPr>
@@ -6992,7 +6992,7 @@
                 <a:ea typeface="Malgun Gothic"/>
                 <a:cs typeface="Malgun Gothic"/>
               </a:rPr>
-              <a:t>만료 access_tokens는 정상 정리 대상이며, 모든 업무 테이블은 복원 전후 동일했습니다.</a:t>
+              <a:t>성공 백업: /var/backups/techflow-flarum/issue-71-20260814T132424Z</a:t>
             </a:r>
           </a:p>
         </p:txBody>
@@ -7000,7 +7000,7 @@
     </p:spTree>
     <p:extLst>
       <p:ext uri="{BB962C8B-B14F-4D97-AF65-F5344CB8AC3E}">
-        <p14:creationId xmlns:p14="http://schemas.microsoft.com/office/powerpoint/2010/main" val="485288822"/>
+        <p14:creationId xmlns:p14="http://schemas.microsoft.com/office/powerpoint/2010/main" val="1773455164"/>
       </p:ext>
     </p:extLst>
   </p:cSld>
@@ -7031,7 +7031,7 @@
           <p:cNvPr id="12" name="">
             <a:extLst xmlns:a="http://schemas.openxmlformats.org/drawingml/2006/main">
               <a:ext uri="{FF2B5EF4-FFF2-40B4-BE49-F238E27FC236}">
-                <a16:creationId xmlns:a16="http://schemas.microsoft.com/office/drawing/2014/main" id="{A2A74853-E5E3-4237-9608-70FB491BC9F3}"/>
+                <a16:creationId xmlns:a16="http://schemas.microsoft.com/office/drawing/2014/main" id="{0F4D5E1B-F893-4C14-8D8D-CECCF2A673B5}"/>
               </a:ext>
             </a:extLst>
           </p:cNvPr>
@@ -7089,7 +7089,7 @@
           <p:cNvPr id="2" name="">
             <a:extLst xmlns:a="http://schemas.openxmlformats.org/drawingml/2006/main">
               <a:ext uri="{FF2B5EF4-FFF2-40B4-BE49-F238E27FC236}">
-                <a16:creationId xmlns:a16="http://schemas.microsoft.com/office/drawing/2014/main" id="{E49716FF-5821-462B-B951-4AD961E3466D}"/>
+                <a16:creationId xmlns:a16="http://schemas.microsoft.com/office/drawing/2014/main" id="{B8A581E0-8F62-4537-ADD5-5E8AC7DA4DBD}"/>
               </a:ext>
             </a:extLst>
           </p:cNvPr>
@@ -7137,7 +7137,7 @@
                 <a:ea typeface="Malgun Gothic"/>
                 <a:cs typeface="Malgun Gothic"/>
               </a:rPr>
-              <a:t>사용자 기능과 TechFlow 자동화 경계를 함께 확인했습니다</a:t>
+              <a:t>Community 화면과 TechFlow 자동화가 함께 회복됐습니다</a:t>
             </a:r>
           </a:p>
         </p:txBody>
@@ -7169,7 +7169,7 @@
           <p:cNvPr id="4" name="">
             <a:extLst xmlns:a="http://schemas.openxmlformats.org/drawingml/2006/main">
               <a:ext uri="{FF2B5EF4-FFF2-40B4-BE49-F238E27FC236}">
-                <a16:creationId xmlns:a16="http://schemas.microsoft.com/office/drawing/2014/main" id="{B9C18735-35D1-44A4-90BD-000BD7C496FA}"/>
+                <a16:creationId xmlns:a16="http://schemas.microsoft.com/office/drawing/2014/main" id="{635C7A52-730F-45E2-857C-8D7635579611}"/>
               </a:ext>
             </a:extLst>
           </p:cNvPr>
@@ -7227,7 +7227,7 @@
           <p:cNvPr id="5" name="">
             <a:extLst xmlns:a="http://schemas.openxmlformats.org/drawingml/2006/main">
               <a:ext uri="{FF2B5EF4-FFF2-40B4-BE49-F238E27FC236}">
-                <a16:creationId xmlns:a16="http://schemas.microsoft.com/office/drawing/2014/main" id="{D3943972-6628-4FC8-B1A8-8C995B051D7C}"/>
+                <a16:creationId xmlns:a16="http://schemas.microsoft.com/office/drawing/2014/main" id="{43F41CE7-71C7-4DC6-9ABF-A9CA527E355D}"/>
               </a:ext>
             </a:extLst>
           </p:cNvPr>
@@ -7275,7 +7275,7 @@
                 <a:ea typeface="Malgun Gothic"/>
                 <a:cs typeface="Malgun Gothic"/>
               </a:rPr>
-              <a:t>실제 사용자 시나리오</a:t>
+              <a:t>운영 Community</a:t>
             </a:r>
           </a:p>
         </p:txBody>
@@ -7285,7 +7285,7 @@
           <p:cNvPr id="6" name="">
             <a:extLst xmlns:a="http://schemas.openxmlformats.org/drawingml/2006/main">
               <a:ext uri="{FF2B5EF4-FFF2-40B4-BE49-F238E27FC236}">
-                <a16:creationId xmlns:a16="http://schemas.microsoft.com/office/drawing/2014/main" id="{C4069E63-EA77-423D-85C1-3C48423C7158}"/>
+                <a16:creationId xmlns:a16="http://schemas.microsoft.com/office/drawing/2014/main" id="{A586857C-F9F0-45D3-B5AF-73108BDED772}"/>
               </a:ext>
             </a:extLst>
           </p:cNvPr>
@@ -7333,7 +7333,7 @@
                 <a:ea typeface="Malgun Gothic"/>
                 <a:cs typeface="Malgun Gothic"/>
               </a:rPr>
-              <a:t>격리한 외부 연동</a:t>
+              <a:t>TechFlow 통합</a:t>
             </a:r>
           </a:p>
         </p:txBody>
@@ -7343,7 +7343,7 @@
           <p:cNvPr id="7" name="">
             <a:extLst xmlns:a="http://schemas.openxmlformats.org/drawingml/2006/main">
               <a:ext uri="{FF2B5EF4-FFF2-40B4-BE49-F238E27FC236}">
-                <a16:creationId xmlns:a16="http://schemas.microsoft.com/office/drawing/2014/main" id="{C6CF7E81-669D-4F06-BEE8-400564F849EB}"/>
+                <a16:creationId xmlns:a16="http://schemas.microsoft.com/office/drawing/2014/main" id="{92E22C36-F260-4B96-AF6A-B34041559F59}"/>
               </a:ext>
             </a:extLst>
           </p:cNvPr>
@@ -7376,7 +7376,7 @@
           <p:cNvPr id="8" name="">
             <a:extLst xmlns:a="http://schemas.openxmlformats.org/drawingml/2006/main">
               <a:ext uri="{FF2B5EF4-FFF2-40B4-BE49-F238E27FC236}">
-                <a16:creationId xmlns:a16="http://schemas.microsoft.com/office/drawing/2014/main" id="{63875544-1DFF-4FB9-9D31-919A93BFB379}"/>
+                <a16:creationId xmlns:a16="http://schemas.microsoft.com/office/drawing/2014/main" id="{7AEE9B81-B06B-469A-B7D8-912EB4524F62}"/>
               </a:ext>
             </a:extLst>
           </p:cNvPr>
@@ -7409,7 +7409,7 @@
           <p:cNvPr id="9" name="">
             <a:extLst xmlns:a="http://schemas.openxmlformats.org/drawingml/2006/main">
               <a:ext uri="{FF2B5EF4-FFF2-40B4-BE49-F238E27FC236}">
-                <a16:creationId xmlns:a16="http://schemas.microsoft.com/office/drawing/2014/main" id="{91B5A362-E56D-4AE3-8A5D-4ECFA46288D5}"/>
+                <a16:creationId xmlns:a16="http://schemas.microsoft.com/office/drawing/2014/main" id="{F756EFD6-7CE4-4731-94B8-E6ECC0D540FB}"/>
               </a:ext>
             </a:extLst>
           </p:cNvPr>
@@ -7457,7 +7457,7 @@
                 <a:ea typeface="Malgun Gothic"/>
                 <a:cs typeface="Malgun Gothic"/>
               </a:rPr>
-              <a:t>로그인</a:t>
+              <a:t>첫 화면 HTTP 200</a:t>
             </a:r>
           </a:p>
           <a:p xmlns:a="http://schemas.openxmlformats.org/drawingml/2006/main">
@@ -7480,7 +7480,7 @@
                 <a:ea typeface="Malgun Gothic"/>
                 <a:cs typeface="Malgun Gothic"/>
               </a:rPr>
-              <a:t>토론 생성과 답글</a:t>
+              <a:t>토론 상세 화면 정상</a:t>
             </a:r>
           </a:p>
           <a:p xmlns:a="http://schemas.openxmlformats.org/drawingml/2006/main">
@@ -7503,7 +7503,7 @@
                 <a:ea typeface="Malgun Gothic"/>
                 <a:cs typeface="Malgun Gothic"/>
               </a:rPr>
-              <a:t>검색</a:t>
+              <a:t>한국어 내부 키 0건</a:t>
             </a:r>
           </a:p>
           <a:p xmlns:a="http://schemas.openxmlformats.org/drawingml/2006/main">
@@ -7526,7 +7526,7 @@
                 <a:ea typeface="Malgun Gothic"/>
                 <a:cs typeface="Malgun Gothic"/>
               </a:rPr>
-              <a:t>이미지 첨부</a:t>
+              <a:t>브라우저 콘솔 오류 0건</a:t>
             </a:r>
           </a:p>
           <a:p xmlns:a="http://schemas.openxmlformats.org/drawingml/2006/main">
@@ -7549,7 +7549,7 @@
                 <a:ea typeface="Malgun Gothic"/>
                 <a:cs typeface="Malgun Gothic"/>
               </a:rPr>
-              <a:t>Best Answer 지정</a:t>
+              <a:t>Flarum CLI 1.8.18 확인</a:t>
             </a:r>
           </a:p>
         </p:txBody>
@@ -7559,7 +7559,7 @@
           <p:cNvPr id="10" name="">
             <a:extLst xmlns:a="http://schemas.openxmlformats.org/drawingml/2006/main">
               <a:ext uri="{FF2B5EF4-FFF2-40B4-BE49-F238E27FC236}">
-                <a16:creationId xmlns:a16="http://schemas.microsoft.com/office/drawing/2014/main" id="{F6F7D167-BF3A-449A-B6D0-9C5997A9E69A}"/>
+                <a16:creationId xmlns:a16="http://schemas.microsoft.com/office/drawing/2014/main" id="{0F300150-6BED-4C34-A434-0EC61BA295CC}"/>
               </a:ext>
             </a:extLst>
           </p:cNvPr>
@@ -7607,12 +7607,7 @@
                 <a:ea typeface="Malgun Gothic"/>
                 <a:cs typeface="Malgun Gothic"/>
               </a:rPr>
-              <a:t>Webhook · OAuth · Pusher · Scout</a:t>
-            </a:r>
-          </a:p>
-          <a:p xmlns:a="http://schemas.openxmlformats.org/drawingml/2006/main">
-            <a:r>
-              <a:t/>
+              <a:t>Community poller 자동 회복</a:t>
             </a:r>
           </a:p>
           <a:p xmlns:a="http://schemas.openxmlformats.org/drawingml/2006/main">
@@ -7635,7 +7630,7 @@
                 <a:ea typeface="Malgun Gothic"/>
                 <a:cs typeface="Malgun Gothic"/>
               </a:rPr>
-              <a:t>스테이징 발송은 끄고</a:t>
+              <a:t>반복 poll failed=0</a:t>
             </a:r>
           </a:p>
           <a:p xmlns:a="http://schemas.openxmlformats.org/drawingml/2006/main">
@@ -7658,7 +7653,7 @@
                 <a:ea typeface="Malgun Gothic"/>
                 <a:cs typeface="Malgun Gothic"/>
               </a:rPr>
-              <a:t>216개 TechFlow 테스트로</a:t>
+              <a:t>AI Gateway healthy</a:t>
             </a:r>
           </a:p>
           <a:p xmlns:a="http://schemas.openxmlformats.org/drawingml/2006/main">
@@ -7681,7 +7676,30 @@
                 <a:ea typeface="Malgun Gothic"/>
                 <a:cs typeface="Malgun Gothic"/>
               </a:rPr>
-              <a:t>AI 답변·Chat·대화·KB 계약 확인</a:t>
+              <a:t>Activepieces healthy</a:t>
+            </a:r>
+          </a:p>
+          <a:p xmlns:a="http://schemas.openxmlformats.org/drawingml/2006/main">
+            <a:pPr algn="l">
+              <a:defRPr sz="1650" b="1">
+                <a:solidFill>
+                  <a:srgbClr val="101010"/>
+                </a:solidFill>
+                <a:latin typeface="Malgun Gothic"/>
+                <a:ea typeface="Malgun Gothic"/>
+                <a:cs typeface="Malgun Gothic"/>
+              </a:defRPr>
+            </a:pPr>
+            <a:r>
+              <a:rPr sz="1650" b="1">
+                <a:solidFill>
+                  <a:srgbClr val="101010"/>
+                </a:solidFill>
+                <a:latin typeface="Malgun Gothic"/>
+                <a:ea typeface="Malgun Gothic"/>
+                <a:cs typeface="Malgun Gothic"/>
+              </a:rPr>
+              <a:t>GitHub→Chat guard PASS</a:t>
             </a:r>
           </a:p>
         </p:txBody>
@@ -7691,7 +7709,7 @@
           <p:cNvPr id="11" name="">
             <a:extLst xmlns:a="http://schemas.openxmlformats.org/drawingml/2006/main">
               <a:ext uri="{FF2B5EF4-FFF2-40B4-BE49-F238E27FC236}">
-                <a16:creationId xmlns:a16="http://schemas.microsoft.com/office/drawing/2014/main" id="{015547E9-1E2C-4CEE-8777-647F89812A17}"/>
+                <a16:creationId xmlns:a16="http://schemas.microsoft.com/office/drawing/2014/main" id="{2BCBE022-1E99-486B-BCD9-00E76753BF14}"/>
               </a:ext>
             </a:extLst>
           </p:cNvPr>
@@ -7739,7 +7757,7 @@
                 <a:ea typeface="Malgun Gothic"/>
                 <a:cs typeface="Malgun Gothic"/>
               </a:rPr>
-              <a:t>로그·압축 업로드는 #72에서 확장하고 별도 E2E를 수행합니다.</a:t>
+              <a:t>Admin 외부 403은 기존 접근 정책이며 공개 사용자 경로와 Flarum CLI로 운영 상태를 검증했습니다.</a:t>
             </a:r>
           </a:p>
         </p:txBody>
@@ -7747,7 +7765,7 @@
     </p:spTree>
     <p:extLst>
       <p:ext uri="{BB962C8B-B14F-4D97-AF65-F5344CB8AC3E}">
-        <p14:creationId xmlns:p14="http://schemas.microsoft.com/office/powerpoint/2010/main" val="1585668274"/>
+        <p14:creationId xmlns:p14="http://schemas.microsoft.com/office/powerpoint/2010/main" val="1299992041"/>
       </p:ext>
     </p:extLst>
   </p:cSld>
@@ -7778,7 +7796,7 @@
           <p:cNvPr id="13" name="">
             <a:extLst xmlns:a="http://schemas.openxmlformats.org/drawingml/2006/main">
               <a:ext uri="{FF2B5EF4-FFF2-40B4-BE49-F238E27FC236}">
-                <a16:creationId xmlns:a16="http://schemas.microsoft.com/office/drawing/2014/main" id="{BDD51B6A-C774-44D7-9568-1E370A52D9BD}"/>
+                <a16:creationId xmlns:a16="http://schemas.microsoft.com/office/drawing/2014/main" id="{D7FCD73B-50C1-420F-A7D7-380D8F619E49}"/>
               </a:ext>
             </a:extLst>
           </p:cNvPr>
@@ -7836,7 +7854,7 @@
           <p:cNvPr id="2" name="">
             <a:extLst xmlns:a="http://schemas.openxmlformats.org/drawingml/2006/main">
               <a:ext uri="{FF2B5EF4-FFF2-40B4-BE49-F238E27FC236}">
-                <a16:creationId xmlns:a16="http://schemas.microsoft.com/office/drawing/2014/main" id="{FB95C6E5-28B0-4B1C-A0E2-3397445F38F6}"/>
+                <a16:creationId xmlns:a16="http://schemas.microsoft.com/office/drawing/2014/main" id="{80CD11AE-805D-4322-91D6-614E4AE6E4C6}"/>
               </a:ext>
             </a:extLst>
           </p:cNvPr>
@@ -7916,7 +7934,7 @@
           <p:cNvPr id="4" name="">
             <a:extLst xmlns:a="http://schemas.openxmlformats.org/drawingml/2006/main">
               <a:ext uri="{FF2B5EF4-FFF2-40B4-BE49-F238E27FC236}">
-                <a16:creationId xmlns:a16="http://schemas.microsoft.com/office/drawing/2014/main" id="{CDA98070-5CC1-42A1-9BFE-0880F5AAE19A}"/>
+                <a16:creationId xmlns:a16="http://schemas.microsoft.com/office/drawing/2014/main" id="{EB412253-1629-45C7-B34F-47560CB5CD73}"/>
               </a:ext>
             </a:extLst>
           </p:cNvPr>
@@ -7974,7 +7992,7 @@
           <p:cNvPr id="5" name="">
             <a:extLst xmlns:a="http://schemas.openxmlformats.org/drawingml/2006/main">
               <a:ext uri="{FF2B5EF4-FFF2-40B4-BE49-F238E27FC236}">
-                <a16:creationId xmlns:a16="http://schemas.microsoft.com/office/drawing/2014/main" id="{3FE44889-AC75-4689-A7E8-B872D80BBEA7}"/>
+                <a16:creationId xmlns:a16="http://schemas.microsoft.com/office/drawing/2014/main" id="{901E27AA-B74D-4315-B655-1249313CADD1}"/>
               </a:ext>
             </a:extLst>
           </p:cNvPr>
@@ -8007,7 +8025,7 @@
           <p:cNvPr id="6" name="">
             <a:extLst xmlns:a="http://schemas.openxmlformats.org/drawingml/2006/main">
               <a:ext uri="{FF2B5EF4-FFF2-40B4-BE49-F238E27FC236}">
-                <a16:creationId xmlns:a16="http://schemas.microsoft.com/office/drawing/2014/main" id="{4C9E4D59-34E6-4907-9DB3-0CCF130B6183}"/>
+                <a16:creationId xmlns:a16="http://schemas.microsoft.com/office/drawing/2014/main" id="{4AC9138A-F468-4C4D-999B-B4EC04FBA9BD}"/>
               </a:ext>
             </a:extLst>
           </p:cNvPr>
@@ -8065,7 +8083,7 @@
           <p:cNvPr id="7" name="">
             <a:extLst xmlns:a="http://schemas.openxmlformats.org/drawingml/2006/main">
               <a:ext uri="{FF2B5EF4-FFF2-40B4-BE49-F238E27FC236}">
-                <a16:creationId xmlns:a16="http://schemas.microsoft.com/office/drawing/2014/main" id="{0F09B601-0172-4449-8493-CD19FCD47513}"/>
+                <a16:creationId xmlns:a16="http://schemas.microsoft.com/office/drawing/2014/main" id="{7A5B42C2-C344-49B4-84C1-3E1790BB801A}"/>
               </a:ext>
             </a:extLst>
           </p:cNvPr>
@@ -8123,7 +8141,7 @@
           <p:cNvPr id="8" name="">
             <a:extLst xmlns:a="http://schemas.openxmlformats.org/drawingml/2006/main">
               <a:ext uri="{FF2B5EF4-FFF2-40B4-BE49-F238E27FC236}">
-                <a16:creationId xmlns:a16="http://schemas.microsoft.com/office/drawing/2014/main" id="{760D5EB3-211A-4569-97A3-679E7AD16B91}"/>
+                <a16:creationId xmlns:a16="http://schemas.microsoft.com/office/drawing/2014/main" id="{678E2E36-93E2-4774-9CED-4915CD47332C}"/>
               </a:ext>
             </a:extLst>
           </p:cNvPr>
@@ -8156,7 +8174,7 @@
           <p:cNvPr id="9" name="">
             <a:extLst xmlns:a="http://schemas.openxmlformats.org/drawingml/2006/main">
               <a:ext uri="{FF2B5EF4-FFF2-40B4-BE49-F238E27FC236}">
-                <a16:creationId xmlns:a16="http://schemas.microsoft.com/office/drawing/2014/main" id="{37B1FA49-1CF8-460E-85F8-ABE72EF6019A}"/>
+                <a16:creationId xmlns:a16="http://schemas.microsoft.com/office/drawing/2014/main" id="{66040603-C553-448C-BEC1-1E747D69AB67}"/>
               </a:ext>
             </a:extLst>
           </p:cNvPr>
@@ -8214,7 +8232,7 @@
           <p:cNvPr id="10" name="">
             <a:extLst xmlns:a="http://schemas.openxmlformats.org/drawingml/2006/main">
               <a:ext uri="{FF2B5EF4-FFF2-40B4-BE49-F238E27FC236}">
-                <a16:creationId xmlns:a16="http://schemas.microsoft.com/office/drawing/2014/main" id="{C967CC77-3326-4329-B0CD-CC3B21EA0FC9}"/>
+                <a16:creationId xmlns:a16="http://schemas.microsoft.com/office/drawing/2014/main" id="{B38D0DA1-80C0-4BA5-9C49-B38739BF1D47}"/>
               </a:ext>
             </a:extLst>
           </p:cNvPr>
@@ -8272,7 +8290,7 @@
           <p:cNvPr id="11" name="">
             <a:extLst xmlns:a="http://schemas.openxmlformats.org/drawingml/2006/main">
               <a:ext uri="{FF2B5EF4-FFF2-40B4-BE49-F238E27FC236}">
-                <a16:creationId xmlns:a16="http://schemas.microsoft.com/office/drawing/2014/main" id="{A1091F27-761D-4FD6-94EC-4B26910223E9}"/>
+                <a16:creationId xmlns:a16="http://schemas.microsoft.com/office/drawing/2014/main" id="{51894C46-3309-45D7-8B59-52E1BCFD8562}"/>
               </a:ext>
             </a:extLst>
           </p:cNvPr>
@@ -8330,7 +8348,7 @@
           <p:cNvPr id="12" name="">
             <a:extLst xmlns:a="http://schemas.openxmlformats.org/drawingml/2006/main">
               <a:ext uri="{FF2B5EF4-FFF2-40B4-BE49-F238E27FC236}">
-                <a16:creationId xmlns:a16="http://schemas.microsoft.com/office/drawing/2014/main" id="{9E42B9EF-06D9-457F-9B02-567D1E9378FA}"/>
+                <a16:creationId xmlns:a16="http://schemas.microsoft.com/office/drawing/2014/main" id="{A10D0330-EE94-487C-942A-BA8924B5456B}"/>
               </a:ext>
             </a:extLst>
           </p:cNvPr>
@@ -8378,7 +8396,7 @@
                 <a:ea typeface="Malgun Gothic"/>
                 <a:cs typeface="Malgun Gothic"/>
               </a:rPr>
-              <a:t>운영 규칙: SMTP 유지 · Sendmail 전환 금지 · Issue #74에서 교체 추적</a:t>
+              <a:t>현재 운영 규칙: SMTP 유지 · Sendmail 전환 금지 · Issue #74에서 교체 추적</a:t>
             </a:r>
           </a:p>
         </p:txBody>
@@ -8386,7 +8404,7 @@
     </p:spTree>
     <p:extLst>
       <p:ext uri="{BB962C8B-B14F-4D97-AF65-F5344CB8AC3E}">
-        <p14:creationId xmlns:p14="http://schemas.microsoft.com/office/powerpoint/2010/main" val="2055289712"/>
+        <p14:creationId xmlns:p14="http://schemas.microsoft.com/office/powerpoint/2010/main" val="1441019361"/>
       </p:ext>
     </p:extLst>
   </p:cSld>
@@ -8417,7 +8435,7 @@
           <p:cNvPr id="6" name="">
             <a:extLst xmlns:a="http://schemas.openxmlformats.org/drawingml/2006/main">
               <a:ext uri="{FF2B5EF4-FFF2-40B4-BE49-F238E27FC236}">
-                <a16:creationId xmlns:a16="http://schemas.microsoft.com/office/drawing/2014/main" id="{AFE1E696-0361-4A96-AE69-667C02AE8692}"/>
+                <a16:creationId xmlns:a16="http://schemas.microsoft.com/office/drawing/2014/main" id="{21DB5C8C-4D24-402F-86AC-F975CC98C0DC}"/>
               </a:ext>
             </a:extLst>
           </p:cNvPr>
@@ -8475,7 +8493,7 @@
           <p:cNvPr id="2" name="">
             <a:extLst xmlns:a="http://schemas.openxmlformats.org/drawingml/2006/main">
               <a:ext uri="{FF2B5EF4-FFF2-40B4-BE49-F238E27FC236}">
-                <a16:creationId xmlns:a16="http://schemas.microsoft.com/office/drawing/2014/main" id="{70D409F0-D9A5-4B91-881A-706528092736}"/>
+                <a16:creationId xmlns:a16="http://schemas.microsoft.com/office/drawing/2014/main" id="{C1B19A7A-6152-4F55-8BF8-0A5322F1CC88}"/>
               </a:ext>
             </a:extLst>
           </p:cNvPr>
@@ -8523,7 +8541,7 @@
                 <a:ea typeface="Malgun Gothic"/>
                 <a:cs typeface="Malgun Gothic"/>
               </a:rPr>
-              <a:t>운영 승인 전까지</a:t>
+              <a:t>Issue #71 운영 반영을</a:t>
             </a:r>
           </a:p>
           <a:p xmlns:a="http://schemas.openxmlformats.org/drawingml/2006/main">
@@ -8546,7 +8564,7 @@
                 <a:ea typeface="Malgun Gothic"/>
                 <a:cs typeface="Malgun Gothic"/>
               </a:rPr>
-              <a:t>변경하지 않습니다</a:t>
+              <a:t>완료했습니다</a:t>
             </a:r>
           </a:p>
         </p:txBody>
@@ -8578,7 +8596,7 @@
           <p:cNvPr id="4" name="">
             <a:extLst xmlns:a="http://schemas.openxmlformats.org/drawingml/2006/main">
               <a:ext uri="{FF2B5EF4-FFF2-40B4-BE49-F238E27FC236}">
-                <a16:creationId xmlns:a16="http://schemas.microsoft.com/office/drawing/2014/main" id="{75B84088-C1E3-4A50-A861-26A43EF28CF2}"/>
+                <a16:creationId xmlns:a16="http://schemas.microsoft.com/office/drawing/2014/main" id="{411C4026-E0F5-4781-B3F6-5425442A4700}"/>
               </a:ext>
             </a:extLst>
           </p:cNvPr>
@@ -8626,7 +8644,7 @@
                 <a:ea typeface="Malgun Gothic"/>
                 <a:cs typeface="Malgun Gothic"/>
               </a:rPr>
-              <a:t>승인 후: 백업 → 업데이트 → Community·TechFlow E2E → Go 또는 즉시 롤백</a:t>
+              <a:t>백업 → 자동 롤백 검증 → 점검 보정 → 운영 업데이트 → Community·TechFlow 확인</a:t>
             </a:r>
           </a:p>
         </p:txBody>
@@ -8636,7 +8654,7 @@
           <p:cNvPr id="5" name="">
             <a:extLst xmlns:a="http://schemas.openxmlformats.org/drawingml/2006/main">
               <a:ext uri="{FF2B5EF4-FFF2-40B4-BE49-F238E27FC236}">
-                <a16:creationId xmlns:a16="http://schemas.microsoft.com/office/drawing/2014/main" id="{D74A0AD7-70DA-4E77-889A-8F557D34A346}"/>
+                <a16:creationId xmlns:a16="http://schemas.microsoft.com/office/drawing/2014/main" id="{DCFEBC79-8190-412C-8D0A-B9B73C8BCF1B}"/>
               </a:ext>
             </a:extLst>
           </p:cNvPr>
@@ -8684,7 +8702,7 @@
                 <a:ea typeface="Malgun Gothic"/>
                 <a:cs typeface="Malgun Gothic"/>
               </a:rPr>
-              <a:t>WSL은 1.8.18 검증 상태로 유지 · 다음 #72 대용량 업로드 · #73 UI · #74 운영 강화</a:t>
+              <a:t>다음: #72 대용량 업로드 · #73 UI 현대화 · #74 백업·모니터링·잔여 보안</a:t>
             </a:r>
           </a:p>
         </p:txBody>
@@ -8692,7 +8710,7 @@
     </p:spTree>
     <p:extLst>
       <p:ext uri="{BB962C8B-B14F-4D97-AF65-F5344CB8AC3E}">
-        <p14:creationId xmlns:p14="http://schemas.microsoft.com/office/powerpoint/2010/main" val="88478786"/>
+        <p14:creationId xmlns:p14="http://schemas.microsoft.com/office/powerpoint/2010/main" val="1497448834"/>
       </p:ext>
     </p:extLst>
   </p:cSld>

</xml_diff>